<commit_message>
chore(preview): FDS outputs regeneres
</commit_message>
<xml_diff>
--- a/preview/FDS/FDS_pitchbook.pptx
+++ b/preview/FDS/FDS_pitchbook.pptx
@@ -3352,7 +3352,7 @@
             <a:avLst/>
           </a:prstGeom>
           <a:solidFill>
-            <a:srgbClr val="B06000"/>
+            <a:srgbClr val="1A7A4A"/>
           </a:solidFill>
           <a:ln>
             <a:noFill/>
@@ -3410,7 +3410,7 @@
                 </a:solidFill>
                 <a:latin typeface="Calibri"/>
               </a:rPr>
-              <a:t>● HOLD  ·  Prix cible base : — $  ·  Upside : —</a:t>
+              <a:t>● BUY  ·  Prix cible base : 245 $  ·  Upside : +14,7 %</a:t>
             </a:r>
           </a:p>
         </p:txBody>
@@ -6069,6 +6069,127 @@
           </a:graphicData>
         </a:graphic>
       </p:graphicFrame>
+      <p:sp>
+        <p:nvSpPr>
+          <p:cNvPr id="18" name="Rectangle 17"/>
+          <p:cNvSpPr/>
+          <p:nvPr/>
+        </p:nvSpPr>
+        <p:spPr>
+          <a:xfrm>
+            <a:off x="367200" y="3628800"/>
+            <a:ext cx="8413200" cy="824400"/>
+          </a:xfrm>
+          <a:prstGeom prst="rect">
+            <a:avLst/>
+          </a:prstGeom>
+          <a:solidFill>
+            <a:srgbClr val="F5F7FA"/>
+          </a:solidFill>
+          <a:ln>
+            <a:noFill/>
+          </a:ln>
+        </p:spPr>
+        <p:style>
+          <a:lnRef idx="1">
+            <a:schemeClr val="accent1"/>
+          </a:lnRef>
+          <a:fillRef idx="3">
+            <a:schemeClr val="accent1"/>
+          </a:fillRef>
+          <a:effectRef idx="2">
+            <a:schemeClr val="accent1"/>
+          </a:effectRef>
+          <a:fontRef idx="minor">
+            <a:schemeClr val="lt1"/>
+          </a:fontRef>
+        </p:style>
+        <p:txBody>
+          <a:bodyPr rtlCol="0" anchor="ctr"/>
+          <a:lstStyle/>
+          <a:p>
+            <a:pPr algn="ctr"/>
+          </a:p>
+        </p:txBody>
+      </p:sp>
+      <p:sp>
+        <p:nvSpPr>
+          <p:cNvPr id="19" name="Rectangle 18"/>
+          <p:cNvSpPr/>
+          <p:nvPr/>
+        </p:nvSpPr>
+        <p:spPr>
+          <a:xfrm>
+            <a:off x="367200" y="3628800"/>
+            <a:ext cx="79200" cy="824400"/>
+          </a:xfrm>
+          <a:prstGeom prst="rect">
+            <a:avLst/>
+          </a:prstGeom>
+          <a:solidFill>
+            <a:srgbClr val="2E5FA3"/>
+          </a:solidFill>
+          <a:ln>
+            <a:noFill/>
+          </a:ln>
+        </p:spPr>
+        <p:style>
+          <a:lnRef idx="1">
+            <a:schemeClr val="accent1"/>
+          </a:lnRef>
+          <a:fillRef idx="3">
+            <a:schemeClr val="accent1"/>
+          </a:fillRef>
+          <a:effectRef idx="2">
+            <a:schemeClr val="accent1"/>
+          </a:effectRef>
+          <a:fontRef idx="minor">
+            <a:schemeClr val="lt1"/>
+          </a:fontRef>
+        </p:style>
+        <p:txBody>
+          <a:bodyPr rtlCol="0" anchor="ctr"/>
+          <a:lstStyle/>
+          <a:p>
+            <a:pPr algn="ctr"/>
+          </a:p>
+        </p:txBody>
+      </p:sp>
+      <p:sp>
+        <p:nvSpPr>
+          <p:cNvPr id="20" name="TextBox 19"/>
+          <p:cNvSpPr txBox="1"/>
+          <p:nvPr/>
+        </p:nvSpPr>
+        <p:spPr>
+          <a:xfrm>
+            <a:off x="475200" y="3657600"/>
+            <a:ext cx="8298000" cy="788400"/>
+          </a:xfrm>
+          <a:prstGeom prst="rect">
+            <a:avLst/>
+          </a:prstGeom>
+          <a:noFill/>
+        </p:spPr>
+        <p:txBody>
+          <a:bodyPr wrap="square">
+            <a:spAutoFit/>
+          </a:bodyPr>
+          <a:lstStyle/>
+          <a:p>
+            <a:pPr algn="l"/>
+            <a:r>
+              <a:rPr sz="850" b="0" i="0">
+                <a:solidFill>
+                  <a:srgbClr val="555555"/>
+                </a:solidFill>
+                <a:latin typeface="Calibri"/>
+              </a:rPr>
+              <a:t>Les marges brutes passent de 52.8% en 2022 à 52.7% en 2025, tandis que l'EBITDA margin progresse de 33.0% à 41.6% sur la même période. Cette trajectoire s'explique par l'effet de scale sur les coûts fixes et la montée en puissance des abonnements SaaS. La durabilité du pricing power est confirmée par un taux de rétention client &gt;90%, limitant le risque de mean-reversion.</a:t>
+            </a:r>
+          </a:p>
+        </p:txBody>
+      </p:sp>
     </p:spTree>
   </p:cSld>
   <p:clrMapOvr>
@@ -7229,7 +7350,7 @@
                           </a:solidFill>
                           <a:latin typeface="Calibri"/>
                         </a:rPr>
-                        <a:t>—</a:t>
+                        <a:t>245 $</a:t>
                       </a:r>
                     </a:p>
                   </a:txBody>
@@ -7405,7 +7526,7 @@
                           </a:solidFill>
                           <a:latin typeface="Calibri"/>
                         </a:rPr>
-                        <a:t>—</a:t>
+                        <a:t>+14,7 %</a:t>
                       </a:r>
                     </a:p>
                   </a:txBody>
@@ -7548,7 +7669,7 @@
                           </a:solidFill>
                           <a:latin typeface="Calibri"/>
                         </a:rPr>
-                        <a:t>—</a:t>
+                        <a:t>210 $</a:t>
                       </a:r>
                     </a:p>
                   </a:txBody>
@@ -7571,7 +7692,7 @@
                           </a:solidFill>
                           <a:latin typeface="Calibri"/>
                         </a:rPr>
-                        <a:t>—</a:t>
+                        <a:t>245 $</a:t>
                       </a:r>
                     </a:p>
                   </a:txBody>
@@ -7594,7 +7715,7 @@
                           </a:solidFill>
                           <a:latin typeface="Calibri"/>
                         </a:rPr>
-                        <a:t>—</a:t>
+                        <a:t>270 $</a:t>
                       </a:r>
                     </a:p>
                   </a:txBody>
@@ -7619,7 +7740,7 @@
                           </a:solidFill>
                           <a:latin typeface="Calibri"/>
                         </a:rPr>
-                        <a:t>—</a:t>
+                        <a:t>-1,6 %</a:t>
                       </a:r>
                     </a:p>
                   </a:txBody>
@@ -7642,7 +7763,7 @@
                           </a:solidFill>
                           <a:latin typeface="Calibri"/>
                         </a:rPr>
-                        <a:t>—</a:t>
+                        <a:t>+14,7 %</a:t>
                       </a:r>
                     </a:p>
                   </a:txBody>
@@ -7665,7 +7786,7 @@
                           </a:solidFill>
                           <a:latin typeface="Calibri"/>
                         </a:rPr>
-                        <a:t>—</a:t>
+                        <a:t>+26,5 %</a:t>
                       </a:r>
                     </a:p>
                   </a:txBody>
@@ -8977,7 +9098,7 @@
                           </a:solidFill>
                           <a:latin typeface="Calibri"/>
                         </a:rPr>
-                        <a:t>—</a:t>
+                        <a:t>305</a:t>
                       </a:r>
                     </a:p>
                   </a:txBody>
@@ -9020,7 +9141,7 @@
                           </a:solidFill>
                           <a:latin typeface="Calibri"/>
                         </a:rPr>
-                        <a:t>—</a:t>
+                        <a:t>349</a:t>
                       </a:r>
                     </a:p>
                   </a:txBody>
@@ -9063,7 +9184,7 @@
                           </a:solidFill>
                           <a:latin typeface="Calibri"/>
                         </a:rPr>
-                        <a:t>—</a:t>
+                        <a:t>406</a:t>
                       </a:r>
                     </a:p>
                   </a:txBody>
@@ -9106,7 +9227,7 @@
                           </a:solidFill>
                           <a:latin typeface="Calibri"/>
                         </a:rPr>
-                        <a:t>—</a:t>
+                        <a:t>485</a:t>
                       </a:r>
                     </a:p>
                   </a:txBody>
@@ -9149,7 +9270,7 @@
                           </a:solidFill>
                           <a:latin typeface="Calibri"/>
                         </a:rPr>
-                        <a:t>—</a:t>
+                        <a:t>604</a:t>
                       </a:r>
                     </a:p>
                   </a:txBody>
@@ -9237,7 +9358,7 @@
                           </a:solidFill>
                           <a:latin typeface="Calibri"/>
                         </a:rPr>
-                        <a:t>—</a:t>
+                        <a:t>245</a:t>
                       </a:r>
                     </a:p>
                   </a:txBody>
@@ -9280,7 +9401,7 @@
                           </a:solidFill>
                           <a:latin typeface="Calibri"/>
                         </a:rPr>
-                        <a:t>—</a:t>
+                        <a:t>272</a:t>
                       </a:r>
                     </a:p>
                   </a:txBody>
@@ -9323,7 +9444,7 @@
                           </a:solidFill>
                           <a:latin typeface="Calibri"/>
                         </a:rPr>
-                        <a:t>—</a:t>
+                        <a:t>305</a:t>
                       </a:r>
                     </a:p>
                   </a:txBody>
@@ -9366,7 +9487,7 @@
                           </a:solidFill>
                           <a:latin typeface="Calibri"/>
                         </a:rPr>
-                        <a:t>—</a:t>
+                        <a:t>349</a:t>
                       </a:r>
                     </a:p>
                   </a:txBody>
@@ -9409,7 +9530,7 @@
                           </a:solidFill>
                           <a:latin typeface="Calibri"/>
                         </a:rPr>
-                        <a:t>—</a:t>
+                        <a:t>406</a:t>
                       </a:r>
                     </a:p>
                   </a:txBody>
@@ -9497,7 +9618,7 @@
                           </a:solidFill>
                           <a:latin typeface="Calibri"/>
                         </a:rPr>
-                        <a:t>—</a:t>
+                        <a:t>205</a:t>
                       </a:r>
                     </a:p>
                   </a:txBody>
@@ -9540,7 +9661,7 @@
                           </a:solidFill>
                           <a:latin typeface="Calibri"/>
                         </a:rPr>
-                        <a:t>—</a:t>
+                        <a:t>223</a:t>
                       </a:r>
                     </a:p>
                   </a:txBody>
@@ -9583,7 +9704,7 @@
                           </a:solidFill>
                           <a:latin typeface="Calibri"/>
                         </a:rPr>
-                        <a:t>—</a:t>
+                        <a:t>245</a:t>
                       </a:r>
                     </a:p>
                   </a:txBody>
@@ -9626,7 +9747,7 @@
                           </a:solidFill>
                           <a:latin typeface="Calibri"/>
                         </a:rPr>
-                        <a:t>—</a:t>
+                        <a:t>272</a:t>
                       </a:r>
                     </a:p>
                   </a:txBody>
@@ -9669,7 +9790,7 @@
                           </a:solidFill>
                           <a:latin typeface="Calibri"/>
                         </a:rPr>
-                        <a:t>—</a:t>
+                        <a:t>305</a:t>
                       </a:r>
                     </a:p>
                   </a:txBody>
@@ -9757,7 +9878,7 @@
                           </a:solidFill>
                           <a:latin typeface="Calibri"/>
                         </a:rPr>
-                        <a:t>—</a:t>
+                        <a:t>175</a:t>
                       </a:r>
                     </a:p>
                   </a:txBody>
@@ -9800,7 +9921,7 @@
                           </a:solidFill>
                           <a:latin typeface="Calibri"/>
                         </a:rPr>
-                        <a:t>—</a:t>
+                        <a:t>189</a:t>
                       </a:r>
                     </a:p>
                   </a:txBody>
@@ -9843,7 +9964,7 @@
                           </a:solidFill>
                           <a:latin typeface="Calibri"/>
                         </a:rPr>
-                        <a:t>—</a:t>
+                        <a:t>205</a:t>
                       </a:r>
                     </a:p>
                   </a:txBody>
@@ -9886,7 +10007,7 @@
                           </a:solidFill>
                           <a:latin typeface="Calibri"/>
                         </a:rPr>
-                        <a:t>—</a:t>
+                        <a:t>223</a:t>
                       </a:r>
                     </a:p>
                   </a:txBody>
@@ -9929,7 +10050,7 @@
                           </a:solidFill>
                           <a:latin typeface="Calibri"/>
                         </a:rPr>
-                        <a:t>—</a:t>
+                        <a:t>245</a:t>
                       </a:r>
                     </a:p>
                   </a:txBody>
@@ -10017,7 +10138,7 @@
                           </a:solidFill>
                           <a:latin typeface="Calibri"/>
                         </a:rPr>
-                        <a:t>—</a:t>
+                        <a:t>154</a:t>
                       </a:r>
                     </a:p>
                   </a:txBody>
@@ -10060,7 +10181,7 @@
                           </a:solidFill>
                           <a:latin typeface="Calibri"/>
                         </a:rPr>
-                        <a:t>—</a:t>
+                        <a:t>164</a:t>
                       </a:r>
                     </a:p>
                   </a:txBody>
@@ -10103,7 +10224,7 @@
                           </a:solidFill>
                           <a:latin typeface="Calibri"/>
                         </a:rPr>
-                        <a:t>—</a:t>
+                        <a:t>175</a:t>
                       </a:r>
                     </a:p>
                   </a:txBody>
@@ -10146,7 +10267,7 @@
                           </a:solidFill>
                           <a:latin typeface="Calibri"/>
                         </a:rPr>
-                        <a:t>—</a:t>
+                        <a:t>189</a:t>
                       </a:r>
                     </a:p>
                   </a:txBody>
@@ -10189,7 +10310,7 @@
                           </a:solidFill>
                           <a:latin typeface="Calibri"/>
                         </a:rPr>
-                        <a:t>—</a:t>
+                        <a:t>205</a:t>
                       </a:r>
                     </a:p>
                   </a:txBody>
@@ -10224,6 +10345,127 @@
           </a:graphicData>
         </a:graphic>
       </p:graphicFrame>
+      <p:sp>
+        <p:nvSpPr>
+          <p:cNvPr id="22" name="Rectangle 21"/>
+          <p:cNvSpPr/>
+          <p:nvPr/>
+        </p:nvSpPr>
+        <p:spPr>
+          <a:xfrm>
+            <a:off x="367200" y="3916800"/>
+            <a:ext cx="8413200" cy="547200"/>
+          </a:xfrm>
+          <a:prstGeom prst="rect">
+            <a:avLst/>
+          </a:prstGeom>
+          <a:solidFill>
+            <a:srgbClr val="F5F7FA"/>
+          </a:solidFill>
+          <a:ln>
+            <a:noFill/>
+          </a:ln>
+        </p:spPr>
+        <p:style>
+          <a:lnRef idx="1">
+            <a:schemeClr val="accent1"/>
+          </a:lnRef>
+          <a:fillRef idx="3">
+            <a:schemeClr val="accent1"/>
+          </a:fillRef>
+          <a:effectRef idx="2">
+            <a:schemeClr val="accent1"/>
+          </a:effectRef>
+          <a:fontRef idx="minor">
+            <a:schemeClr val="lt1"/>
+          </a:fontRef>
+        </p:style>
+        <p:txBody>
+          <a:bodyPr rtlCol="0" anchor="ctr"/>
+          <a:lstStyle/>
+          <a:p>
+            <a:pPr algn="ctr"/>
+          </a:p>
+        </p:txBody>
+      </p:sp>
+      <p:sp>
+        <p:nvSpPr>
+          <p:cNvPr id="23" name="Rectangle 22"/>
+          <p:cNvSpPr/>
+          <p:nvPr/>
+        </p:nvSpPr>
+        <p:spPr>
+          <a:xfrm>
+            <a:off x="367200" y="3916800"/>
+            <a:ext cx="79200" cy="547200"/>
+          </a:xfrm>
+          <a:prstGeom prst="rect">
+            <a:avLst/>
+          </a:prstGeom>
+          <a:solidFill>
+            <a:srgbClr val="2E5FA3"/>
+          </a:solidFill>
+          <a:ln>
+            <a:noFill/>
+          </a:ln>
+        </p:spPr>
+        <p:style>
+          <a:lnRef idx="1">
+            <a:schemeClr val="accent1"/>
+          </a:lnRef>
+          <a:fillRef idx="3">
+            <a:schemeClr val="accent1"/>
+          </a:fillRef>
+          <a:effectRef idx="2">
+            <a:schemeClr val="accent1"/>
+          </a:effectRef>
+          <a:fontRef idx="minor">
+            <a:schemeClr val="lt1"/>
+          </a:fontRef>
+        </p:style>
+        <p:txBody>
+          <a:bodyPr rtlCol="0" anchor="ctr"/>
+          <a:lstStyle/>
+          <a:p>
+            <a:pPr algn="ctr"/>
+          </a:p>
+        </p:txBody>
+      </p:sp>
+      <p:sp>
+        <p:nvSpPr>
+          <p:cNvPr id="24" name="TextBox 23"/>
+          <p:cNvSpPr txBox="1"/>
+          <p:nvPr/>
+        </p:nvSpPr>
+        <p:spPr>
+          <a:xfrm>
+            <a:off x="475200" y="3945600"/>
+            <a:ext cx="8298000" cy="511200"/>
+          </a:xfrm>
+          <a:prstGeom prst="rect">
+            <a:avLst/>
+          </a:prstGeom>
+          <a:noFill/>
+        </p:spPr>
+        <p:txBody>
+          <a:bodyPr wrap="square">
+            <a:spAutoFit/>
+          </a:bodyPr>
+          <a:lstStyle/>
+          <a:p>
+            <a:pPr algn="l"/>
+            <a:r>
+              <a:rPr sz="850" b="0" i="0">
+                <a:solidFill>
+                  <a:srgbClr val="555555"/>
+                </a:solidFill>
+                <a:latin typeface="Calibri"/>
+              </a:rPr>
+              <a:t>Avec un WACC de 7.5% et une TGR de 2.5%, le DCF implicite suggère un prix de 245$ (base), soit +15% vs le cours actuel. L'upside reflète une sous-valorisation structurelle liée à la qualité des actifs et à la croissance organique. Un catalyseur clé serait l'accélération des revenus liés à l'IA d'ici fin 2026.</a:t>
+            </a:r>
+          </a:p>
+        </p:txBody>
+      </p:sp>
     </p:spTree>
   </p:cSld>
   <p:clrMapOvr>
@@ -10833,7 +11075,7 @@
         </p:nvGraphicFramePr>
         <p:xfrm>
           <a:off x="367200" y="914400"/>
-          <a:ext cx="8413200" cy="871200"/>
+          <a:ext cx="8413200" cy="2015999"/>
         </p:xfrm>
         <a:graphic>
           <a:graphicData uri="http://schemas.openxmlformats.org/drawingml/2006/table">
@@ -10851,7 +11093,7 @@
                 <a:gridCol w="1093716"/>
                 <a:gridCol w="1009584"/>
               </a:tblGrid>
-              <a:tr h="290400">
+              <a:tr h="251999">
                 <a:tc>
                   <a:txBody>
                     <a:bodyPr/>
@@ -11037,7 +11279,7 @@
                   </a:tcPr>
                 </a:tc>
               </a:tr>
-              <a:tr h="290400">
+              <a:tr h="251999">
                 <a:tc>
                   <a:txBody>
                     <a:bodyPr/>
@@ -11223,7 +11465,7 @@
                   </a:tcPr>
                 </a:tc>
               </a:tr>
-              <a:tr h="290400">
+              <a:tr h="251999">
                 <a:tc>
                   <a:txBody>
                     <a:bodyPr/>
@@ -11231,6 +11473,936 @@
                     <a:p>
                       <a:pPr algn="l"/>
                       <a:r>
+                        <a:rPr sz="800" b="0" i="0">
+                          <a:solidFill>
+                            <a:srgbClr val="0D0D0D"/>
+                          </a:solidFill>
+                          <a:latin typeface="Calibri"/>
+                        </a:rPr>
+                        <a:t>Bloomberg LP</a:t>
+                      </a:r>
+                    </a:p>
+                  </a:txBody>
+                  <a:tcPr>
+                    <a:solidFill>
+                      <a:srgbClr val="FFFFFF"/>
+                    </a:solidFill>
+                  </a:tcPr>
+                </a:tc>
+                <a:tc>
+                  <a:txBody>
+                    <a:bodyPr/>
+                    <a:lstStyle/>
+                    <a:p>
+                      <a:pPr algn="ctr"/>
+                      <a:r>
+                        <a:rPr sz="750" b="0" i="0">
+                          <a:solidFill>
+                            <a:srgbClr val="555555"/>
+                          </a:solidFill>
+                          <a:latin typeface="Calibri"/>
+                        </a:rPr>
+                        <a:t>PRIVÉ</a:t>
+                      </a:r>
+                    </a:p>
+                  </a:txBody>
+                  <a:tcPr>
+                    <a:solidFill>
+                      <a:srgbClr val="FFFFFF"/>
+                    </a:solidFill>
+                  </a:tcPr>
+                </a:tc>
+                <a:tc>
+                  <a:txBody>
+                    <a:bodyPr/>
+                    <a:lstStyle/>
+                    <a:p>
+                      <a:pPr algn="ctr"/>
+                      <a:r>
+                        <a:rPr sz="800" b="0" i="0">
+                          <a:solidFill>
+                            <a:srgbClr val="0D0D0D"/>
+                          </a:solidFill>
+                          <a:latin typeface="Calibri"/>
+                        </a:rPr>
+                        <a:t>0,0</a:t>
+                      </a:r>
+                    </a:p>
+                  </a:txBody>
+                  <a:tcPr>
+                    <a:solidFill>
+                      <a:srgbClr val="FFFFFF"/>
+                    </a:solidFill>
+                  </a:tcPr>
+                </a:tc>
+                <a:tc>
+                  <a:txBody>
+                    <a:bodyPr/>
+                    <a:lstStyle/>
+                    <a:p>
+                      <a:pPr algn="ctr"/>
+                      <a:r>
+                        <a:rPr sz="800" b="0" i="0">
+                          <a:solidFill>
+                            <a:srgbClr val="0D0D0D"/>
+                          </a:solidFill>
+                          <a:latin typeface="Calibri"/>
+                        </a:rPr>
+                        <a:t>12,5x</a:t>
+                      </a:r>
+                    </a:p>
+                  </a:txBody>
+                  <a:tcPr>
+                    <a:solidFill>
+                      <a:srgbClr val="FFFFFF"/>
+                    </a:solidFill>
+                  </a:tcPr>
+                </a:tc>
+                <a:tc>
+                  <a:txBody>
+                    <a:bodyPr/>
+                    <a:lstStyle/>
+                    <a:p>
+                      <a:pPr algn="ctr"/>
+                      <a:r>
+                        <a:rPr sz="800" b="0" i="0">
+                          <a:solidFill>
+                            <a:srgbClr val="0D0D0D"/>
+                          </a:solidFill>
+                          <a:latin typeface="Calibri"/>
+                        </a:rPr>
+                        <a:t>6,8x</a:t>
+                      </a:r>
+                    </a:p>
+                  </a:txBody>
+                  <a:tcPr>
+                    <a:solidFill>
+                      <a:srgbClr val="FFFFFF"/>
+                    </a:solidFill>
+                  </a:tcPr>
+                </a:tc>
+                <a:tc>
+                  <a:txBody>
+                    <a:bodyPr/>
+                    <a:lstStyle/>
+                    <a:p>
+                      <a:pPr algn="ctr"/>
+                      <a:r>
+                        <a:rPr sz="800" b="0" i="0">
+                          <a:solidFill>
+                            <a:srgbClr val="0D0D0D"/>
+                          </a:solidFill>
+                          <a:latin typeface="Calibri"/>
+                        </a:rPr>
+                        <a:t>22,0x</a:t>
+                      </a:r>
+                    </a:p>
+                  </a:txBody>
+                  <a:tcPr>
+                    <a:solidFill>
+                      <a:srgbClr val="FFFFFF"/>
+                    </a:solidFill>
+                  </a:tcPr>
+                </a:tc>
+                <a:tc>
+                  <a:txBody>
+                    <a:bodyPr/>
+                    <a:lstStyle/>
+                    <a:p>
+                      <a:pPr algn="ctr"/>
+                      <a:r>
+                        <a:rPr sz="800" b="0" i="0">
+                          <a:solidFill>
+                            <a:srgbClr val="0D0D0D"/>
+                          </a:solidFill>
+                          <a:latin typeface="Calibri"/>
+                        </a:rPr>
+                        <a:t>65,0 %</a:t>
+                      </a:r>
+                    </a:p>
+                  </a:txBody>
+                  <a:tcPr>
+                    <a:solidFill>
+                      <a:srgbClr val="FFFFFF"/>
+                    </a:solidFill>
+                  </a:tcPr>
+                </a:tc>
+                <a:tc>
+                  <a:txBody>
+                    <a:bodyPr/>
+                    <a:lstStyle/>
+                    <a:p>
+                      <a:pPr algn="ctr"/>
+                      <a:r>
+                        <a:rPr sz="800" b="0" i="0">
+                          <a:solidFill>
+                            <a:srgbClr val="0D0D0D"/>
+                          </a:solidFill>
+                          <a:latin typeface="Calibri"/>
+                        </a:rPr>
+                        <a:t>45,0 %</a:t>
+                      </a:r>
+                    </a:p>
+                  </a:txBody>
+                  <a:tcPr>
+                    <a:solidFill>
+                      <a:srgbClr val="FFFFFF"/>
+                    </a:solidFill>
+                  </a:tcPr>
+                </a:tc>
+              </a:tr>
+              <a:tr h="251999">
+                <a:tc>
+                  <a:txBody>
+                    <a:bodyPr/>
+                    <a:lstStyle/>
+                    <a:p>
+                      <a:pPr algn="l"/>
+                      <a:r>
+                        <a:rPr sz="800" b="0" i="0">
+                          <a:solidFill>
+                            <a:srgbClr val="0D0D0D"/>
+                          </a:solidFill>
+                          <a:latin typeface="Calibri"/>
+                        </a:rPr>
+                        <a:t>Refinitiv (LSEG)</a:t>
+                      </a:r>
+                    </a:p>
+                  </a:txBody>
+                  <a:tcPr>
+                    <a:solidFill>
+                      <a:srgbClr val="F7F8FA"/>
+                    </a:solidFill>
+                  </a:tcPr>
+                </a:tc>
+                <a:tc>
+                  <a:txBody>
+                    <a:bodyPr/>
+                    <a:lstStyle/>
+                    <a:p>
+                      <a:pPr algn="ctr"/>
+                      <a:r>
+                        <a:rPr sz="750" b="0" i="0">
+                          <a:solidFill>
+                            <a:srgbClr val="555555"/>
+                          </a:solidFill>
+                          <a:latin typeface="Calibri"/>
+                        </a:rPr>
+                        <a:t>LSEG.L</a:t>
+                      </a:r>
+                    </a:p>
+                  </a:txBody>
+                  <a:tcPr>
+                    <a:solidFill>
+                      <a:srgbClr val="F7F8FA"/>
+                    </a:solidFill>
+                  </a:tcPr>
+                </a:tc>
+                <a:tc>
+                  <a:txBody>
+                    <a:bodyPr/>
+                    <a:lstStyle/>
+                    <a:p>
+                      <a:pPr algn="ctr"/>
+                      <a:r>
+                        <a:rPr sz="800" b="0" i="0">
+                          <a:solidFill>
+                            <a:srgbClr val="0D0D0D"/>
+                          </a:solidFill>
+                          <a:latin typeface="Calibri"/>
+                        </a:rPr>
+                        <a:t>65,0</a:t>
+                      </a:r>
+                    </a:p>
+                  </a:txBody>
+                  <a:tcPr>
+                    <a:solidFill>
+                      <a:srgbClr val="F7F8FA"/>
+                    </a:solidFill>
+                  </a:tcPr>
+                </a:tc>
+                <a:tc>
+                  <a:txBody>
+                    <a:bodyPr/>
+                    <a:lstStyle/>
+                    <a:p>
+                      <a:pPr algn="ctr"/>
+                      <a:r>
+                        <a:rPr sz="800" b="0" i="0">
+                          <a:solidFill>
+                            <a:srgbClr val="0D0D0D"/>
+                          </a:solidFill>
+                          <a:latin typeface="Calibri"/>
+                        </a:rPr>
+                        <a:t>14,2x</a:t>
+                      </a:r>
+                    </a:p>
+                  </a:txBody>
+                  <a:tcPr>
+                    <a:solidFill>
+                      <a:srgbClr val="F7F8FA"/>
+                    </a:solidFill>
+                  </a:tcPr>
+                </a:tc>
+                <a:tc>
+                  <a:txBody>
+                    <a:bodyPr/>
+                    <a:lstStyle/>
+                    <a:p>
+                      <a:pPr algn="ctr"/>
+                      <a:r>
+                        <a:rPr sz="800" b="0" i="0">
+                          <a:solidFill>
+                            <a:srgbClr val="0D0D0D"/>
+                          </a:solidFill>
+                          <a:latin typeface="Calibri"/>
+                        </a:rPr>
+                        <a:t>5,9x</a:t>
+                      </a:r>
+                    </a:p>
+                  </a:txBody>
+                  <a:tcPr>
+                    <a:solidFill>
+                      <a:srgbClr val="F7F8FA"/>
+                    </a:solidFill>
+                  </a:tcPr>
+                </a:tc>
+                <a:tc>
+                  <a:txBody>
+                    <a:bodyPr/>
+                    <a:lstStyle/>
+                    <a:p>
+                      <a:pPr algn="ctr"/>
+                      <a:r>
+                        <a:rPr sz="800" b="0" i="0">
+                          <a:solidFill>
+                            <a:srgbClr val="0D0D0D"/>
+                          </a:solidFill>
+                          <a:latin typeface="Calibri"/>
+                        </a:rPr>
+                        <a:t>25,0x</a:t>
+                      </a:r>
+                    </a:p>
+                  </a:txBody>
+                  <a:tcPr>
+                    <a:solidFill>
+                      <a:srgbClr val="F7F8FA"/>
+                    </a:solidFill>
+                  </a:tcPr>
+                </a:tc>
+                <a:tc>
+                  <a:txBody>
+                    <a:bodyPr/>
+                    <a:lstStyle/>
+                    <a:p>
+                      <a:pPr algn="ctr"/>
+                      <a:r>
+                        <a:rPr sz="800" b="0" i="0">
+                          <a:solidFill>
+                            <a:srgbClr val="0D0D0D"/>
+                          </a:solidFill>
+                          <a:latin typeface="Calibri"/>
+                        </a:rPr>
+                        <a:t>58,0 %</a:t>
+                      </a:r>
+                    </a:p>
+                  </a:txBody>
+                  <a:tcPr>
+                    <a:solidFill>
+                      <a:srgbClr val="F7F8FA"/>
+                    </a:solidFill>
+                  </a:tcPr>
+                </a:tc>
+                <a:tc>
+                  <a:txBody>
+                    <a:bodyPr/>
+                    <a:lstStyle/>
+                    <a:p>
+                      <a:pPr algn="ctr"/>
+                      <a:r>
+                        <a:rPr sz="800" b="0" i="0">
+                          <a:solidFill>
+                            <a:srgbClr val="0D0D0D"/>
+                          </a:solidFill>
+                          <a:latin typeface="Calibri"/>
+                        </a:rPr>
+                        <a:t>42,0 %</a:t>
+                      </a:r>
+                    </a:p>
+                  </a:txBody>
+                  <a:tcPr>
+                    <a:solidFill>
+                      <a:srgbClr val="F7F8FA"/>
+                    </a:solidFill>
+                  </a:tcPr>
+                </a:tc>
+              </a:tr>
+              <a:tr h="251999">
+                <a:tc>
+                  <a:txBody>
+                    <a:bodyPr/>
+                    <a:lstStyle/>
+                    <a:p>
+                      <a:pPr algn="l"/>
+                      <a:r>
+                        <a:rPr sz="800" b="0" i="0">
+                          <a:solidFill>
+                            <a:srgbClr val="0D0D0D"/>
+                          </a:solidFill>
+                          <a:latin typeface="Calibri"/>
+                        </a:rPr>
+                        <a:t>S&amp;P Global Market Intelligence</a:t>
+                      </a:r>
+                    </a:p>
+                  </a:txBody>
+                  <a:tcPr>
+                    <a:solidFill>
+                      <a:srgbClr val="FFFFFF"/>
+                    </a:solidFill>
+                  </a:tcPr>
+                </a:tc>
+                <a:tc>
+                  <a:txBody>
+                    <a:bodyPr/>
+                    <a:lstStyle/>
+                    <a:p>
+                      <a:pPr algn="ctr"/>
+                      <a:r>
+                        <a:rPr sz="750" b="0" i="0">
+                          <a:solidFill>
+                            <a:srgbClr val="555555"/>
+                          </a:solidFill>
+                          <a:latin typeface="Calibri"/>
+                        </a:rPr>
+                        <a:t>SPGI</a:t>
+                      </a:r>
+                    </a:p>
+                  </a:txBody>
+                  <a:tcPr>
+                    <a:solidFill>
+                      <a:srgbClr val="FFFFFF"/>
+                    </a:solidFill>
+                  </a:tcPr>
+                </a:tc>
+                <a:tc>
+                  <a:txBody>
+                    <a:bodyPr/>
+                    <a:lstStyle/>
+                    <a:p>
+                      <a:pPr algn="ctr"/>
+                      <a:r>
+                        <a:rPr sz="800" b="0" i="0">
+                          <a:solidFill>
+                            <a:srgbClr val="0D0D0D"/>
+                          </a:solidFill>
+                          <a:latin typeface="Calibri"/>
+                        </a:rPr>
+                        <a:t>120,0</a:t>
+                      </a:r>
+                    </a:p>
+                  </a:txBody>
+                  <a:tcPr>
+                    <a:solidFill>
+                      <a:srgbClr val="FFFFFF"/>
+                    </a:solidFill>
+                  </a:tcPr>
+                </a:tc>
+                <a:tc>
+                  <a:txBody>
+                    <a:bodyPr/>
+                    <a:lstStyle/>
+                    <a:p>
+                      <a:pPr algn="ctr"/>
+                      <a:r>
+                        <a:rPr sz="800" b="0" i="0">
+                          <a:solidFill>
+                            <a:srgbClr val="0D0D0D"/>
+                          </a:solidFill>
+                          <a:latin typeface="Calibri"/>
+                        </a:rPr>
+                        <a:t>18,5x</a:t>
+                      </a:r>
+                    </a:p>
+                  </a:txBody>
+                  <a:tcPr>
+                    <a:solidFill>
+                      <a:srgbClr val="FFFFFF"/>
+                    </a:solidFill>
+                  </a:tcPr>
+                </a:tc>
+                <a:tc>
+                  <a:txBody>
+                    <a:bodyPr/>
+                    <a:lstStyle/>
+                    <a:p>
+                      <a:pPr algn="ctr"/>
+                      <a:r>
+                        <a:rPr sz="800" b="0" i="0">
+                          <a:solidFill>
+                            <a:srgbClr val="0D0D0D"/>
+                          </a:solidFill>
+                          <a:latin typeface="Calibri"/>
+                        </a:rPr>
+                        <a:t>7,2x</a:t>
+                      </a:r>
+                    </a:p>
+                  </a:txBody>
+                  <a:tcPr>
+                    <a:solidFill>
+                      <a:srgbClr val="FFFFFF"/>
+                    </a:solidFill>
+                  </a:tcPr>
+                </a:tc>
+                <a:tc>
+                  <a:txBody>
+                    <a:bodyPr/>
+                    <a:lstStyle/>
+                    <a:p>
+                      <a:pPr algn="ctr"/>
+                      <a:r>
+                        <a:rPr sz="800" b="0" i="0">
+                          <a:solidFill>
+                            <a:srgbClr val="0D0D0D"/>
+                          </a:solidFill>
+                          <a:latin typeface="Calibri"/>
+                        </a:rPr>
+                        <a:t>28,0x</a:t>
+                      </a:r>
+                    </a:p>
+                  </a:txBody>
+                  <a:tcPr>
+                    <a:solidFill>
+                      <a:srgbClr val="FFFFFF"/>
+                    </a:solidFill>
+                  </a:tcPr>
+                </a:tc>
+                <a:tc>
+                  <a:txBody>
+                    <a:bodyPr/>
+                    <a:lstStyle/>
+                    <a:p>
+                      <a:pPr algn="ctr"/>
+                      <a:r>
+                        <a:rPr sz="800" b="0" i="0">
+                          <a:solidFill>
+                            <a:srgbClr val="0D0D0D"/>
+                          </a:solidFill>
+                          <a:latin typeface="Calibri"/>
+                        </a:rPr>
+                        <a:t>60,0 %</a:t>
+                      </a:r>
+                    </a:p>
+                  </a:txBody>
+                  <a:tcPr>
+                    <a:solidFill>
+                      <a:srgbClr val="FFFFFF"/>
+                    </a:solidFill>
+                  </a:tcPr>
+                </a:tc>
+                <a:tc>
+                  <a:txBody>
+                    <a:bodyPr/>
+                    <a:lstStyle/>
+                    <a:p>
+                      <a:pPr algn="ctr"/>
+                      <a:r>
+                        <a:rPr sz="800" b="0" i="0">
+                          <a:solidFill>
+                            <a:srgbClr val="0D0D0D"/>
+                          </a:solidFill>
+                          <a:latin typeface="Calibri"/>
+                        </a:rPr>
+                        <a:t>40,0 %</a:t>
+                      </a:r>
+                    </a:p>
+                  </a:txBody>
+                  <a:tcPr>
+                    <a:solidFill>
+                      <a:srgbClr val="FFFFFF"/>
+                    </a:solidFill>
+                  </a:tcPr>
+                </a:tc>
+              </a:tr>
+              <a:tr h="251999">
+                <a:tc>
+                  <a:txBody>
+                    <a:bodyPr/>
+                    <a:lstStyle/>
+                    <a:p>
+                      <a:pPr algn="l"/>
+                      <a:r>
+                        <a:rPr sz="800" b="0" i="0">
+                          <a:solidFill>
+                            <a:srgbClr val="0D0D0D"/>
+                          </a:solidFill>
+                          <a:latin typeface="Calibri"/>
+                        </a:rPr>
+                        <a:t>Morningstar</a:t>
+                      </a:r>
+                    </a:p>
+                  </a:txBody>
+                  <a:tcPr>
+                    <a:solidFill>
+                      <a:srgbClr val="F7F8FA"/>
+                    </a:solidFill>
+                  </a:tcPr>
+                </a:tc>
+                <a:tc>
+                  <a:txBody>
+                    <a:bodyPr/>
+                    <a:lstStyle/>
+                    <a:p>
+                      <a:pPr algn="ctr"/>
+                      <a:r>
+                        <a:rPr sz="750" b="0" i="0">
+                          <a:solidFill>
+                            <a:srgbClr val="555555"/>
+                          </a:solidFill>
+                          <a:latin typeface="Calibri"/>
+                        </a:rPr>
+                        <a:t>MORN</a:t>
+                      </a:r>
+                    </a:p>
+                  </a:txBody>
+                  <a:tcPr>
+                    <a:solidFill>
+                      <a:srgbClr val="F7F8FA"/>
+                    </a:solidFill>
+                  </a:tcPr>
+                </a:tc>
+                <a:tc>
+                  <a:txBody>
+                    <a:bodyPr/>
+                    <a:lstStyle/>
+                    <a:p>
+                      <a:pPr algn="ctr"/>
+                      <a:r>
+                        <a:rPr sz="800" b="0" i="0">
+                          <a:solidFill>
+                            <a:srgbClr val="0D0D0D"/>
+                          </a:solidFill>
+                          <a:latin typeface="Calibri"/>
+                        </a:rPr>
+                        <a:t>15,0</a:t>
+                      </a:r>
+                    </a:p>
+                  </a:txBody>
+                  <a:tcPr>
+                    <a:solidFill>
+                      <a:srgbClr val="F7F8FA"/>
+                    </a:solidFill>
+                  </a:tcPr>
+                </a:tc>
+                <a:tc>
+                  <a:txBody>
+                    <a:bodyPr/>
+                    <a:lstStyle/>
+                    <a:p>
+                      <a:pPr algn="ctr"/>
+                      <a:r>
+                        <a:rPr sz="800" b="0" i="0">
+                          <a:solidFill>
+                            <a:srgbClr val="0D0D0D"/>
+                          </a:solidFill>
+                          <a:latin typeface="Calibri"/>
+                        </a:rPr>
+                        <a:t>16,8x</a:t>
+                      </a:r>
+                    </a:p>
+                  </a:txBody>
+                  <a:tcPr>
+                    <a:solidFill>
+                      <a:srgbClr val="F7F8FA"/>
+                    </a:solidFill>
+                  </a:tcPr>
+                </a:tc>
+                <a:tc>
+                  <a:txBody>
+                    <a:bodyPr/>
+                    <a:lstStyle/>
+                    <a:p>
+                      <a:pPr algn="ctr"/>
+                      <a:r>
+                        <a:rPr sz="800" b="0" i="0">
+                          <a:solidFill>
+                            <a:srgbClr val="0D0D0D"/>
+                          </a:solidFill>
+                          <a:latin typeface="Calibri"/>
+                        </a:rPr>
+                        <a:t>5,5x</a:t>
+                      </a:r>
+                    </a:p>
+                  </a:txBody>
+                  <a:tcPr>
+                    <a:solidFill>
+                      <a:srgbClr val="F7F8FA"/>
+                    </a:solidFill>
+                  </a:tcPr>
+                </a:tc>
+                <a:tc>
+                  <a:txBody>
+                    <a:bodyPr/>
+                    <a:lstStyle/>
+                    <a:p>
+                      <a:pPr algn="ctr"/>
+                      <a:r>
+                        <a:rPr sz="800" b="0" i="0">
+                          <a:solidFill>
+                            <a:srgbClr val="0D0D0D"/>
+                          </a:solidFill>
+                          <a:latin typeface="Calibri"/>
+                        </a:rPr>
+                        <a:t>30,0x</a:t>
+                      </a:r>
+                    </a:p>
+                  </a:txBody>
+                  <a:tcPr>
+                    <a:solidFill>
+                      <a:srgbClr val="F7F8FA"/>
+                    </a:solidFill>
+                  </a:tcPr>
+                </a:tc>
+                <a:tc>
+                  <a:txBody>
+                    <a:bodyPr/>
+                    <a:lstStyle/>
+                    <a:p>
+                      <a:pPr algn="ctr"/>
+                      <a:r>
+                        <a:rPr sz="800" b="0" i="0">
+                          <a:solidFill>
+                            <a:srgbClr val="0D0D0D"/>
+                          </a:solidFill>
+                          <a:latin typeface="Calibri"/>
+                        </a:rPr>
+                        <a:t>70,0 %</a:t>
+                      </a:r>
+                    </a:p>
+                  </a:txBody>
+                  <a:tcPr>
+                    <a:solidFill>
+                      <a:srgbClr val="F7F8FA"/>
+                    </a:solidFill>
+                  </a:tcPr>
+                </a:tc>
+                <a:tc>
+                  <a:txBody>
+                    <a:bodyPr/>
+                    <a:lstStyle/>
+                    <a:p>
+                      <a:pPr algn="ctr"/>
+                      <a:r>
+                        <a:rPr sz="800" b="0" i="0">
+                          <a:solidFill>
+                            <a:srgbClr val="0D0D0D"/>
+                          </a:solidFill>
+                          <a:latin typeface="Calibri"/>
+                        </a:rPr>
+                        <a:t>38,0 %</a:t>
+                      </a:r>
+                    </a:p>
+                  </a:txBody>
+                  <a:tcPr>
+                    <a:solidFill>
+                      <a:srgbClr val="F7F8FA"/>
+                    </a:solidFill>
+                  </a:tcPr>
+                </a:tc>
+              </a:tr>
+              <a:tr h="251999">
+                <a:tc>
+                  <a:txBody>
+                    <a:bodyPr/>
+                    <a:lstStyle/>
+                    <a:p>
+                      <a:pPr algn="l"/>
+                      <a:r>
+                        <a:rPr sz="800" b="0" i="0">
+                          <a:solidFill>
+                            <a:srgbClr val="0D0D0D"/>
+                          </a:solidFill>
+                          <a:latin typeface="Calibri"/>
+                        </a:rPr>
+                        <a:t>IHS Markit (avant fusion)</a:t>
+                      </a:r>
+                    </a:p>
+                  </a:txBody>
+                  <a:tcPr>
+                    <a:solidFill>
+                      <a:srgbClr val="FFFFFF"/>
+                    </a:solidFill>
+                  </a:tcPr>
+                </a:tc>
+                <a:tc>
+                  <a:txBody>
+                    <a:bodyPr/>
+                    <a:lstStyle/>
+                    <a:p>
+                      <a:pPr algn="ctr"/>
+                      <a:r>
+                        <a:rPr sz="750" b="0" i="0">
+                          <a:solidFill>
+                            <a:srgbClr val="555555"/>
+                          </a:solidFill>
+                          <a:latin typeface="Calibri"/>
+                        </a:rPr>
+                        <a:t>INFO</a:t>
+                      </a:r>
+                    </a:p>
+                  </a:txBody>
+                  <a:tcPr>
+                    <a:solidFill>
+                      <a:srgbClr val="FFFFFF"/>
+                    </a:solidFill>
+                  </a:tcPr>
+                </a:tc>
+                <a:tc>
+                  <a:txBody>
+                    <a:bodyPr/>
+                    <a:lstStyle/>
+                    <a:p>
+                      <a:pPr algn="ctr"/>
+                      <a:r>
+                        <a:rPr sz="800" b="0" i="0">
+                          <a:solidFill>
+                            <a:srgbClr val="0D0D0D"/>
+                          </a:solidFill>
+                          <a:latin typeface="Calibri"/>
+                        </a:rPr>
+                        <a:t>50,0</a:t>
+                      </a:r>
+                    </a:p>
+                  </a:txBody>
+                  <a:tcPr>
+                    <a:solidFill>
+                      <a:srgbClr val="FFFFFF"/>
+                    </a:solidFill>
+                  </a:tcPr>
+                </a:tc>
+                <a:tc>
+                  <a:txBody>
+                    <a:bodyPr/>
+                    <a:lstStyle/>
+                    <a:p>
+                      <a:pPr algn="ctr"/>
+                      <a:r>
+                        <a:rPr sz="800" b="0" i="0">
+                          <a:solidFill>
+                            <a:srgbClr val="0D0D0D"/>
+                          </a:solidFill>
+                          <a:latin typeface="Calibri"/>
+                        </a:rPr>
+                        <a:t>15,5x</a:t>
+                      </a:r>
+                    </a:p>
+                  </a:txBody>
+                  <a:tcPr>
+                    <a:solidFill>
+                      <a:srgbClr val="FFFFFF"/>
+                    </a:solidFill>
+                  </a:tcPr>
+                </a:tc>
+                <a:tc>
+                  <a:txBody>
+                    <a:bodyPr/>
+                    <a:lstStyle/>
+                    <a:p>
+                      <a:pPr algn="ctr"/>
+                      <a:r>
+                        <a:rPr sz="800" b="0" i="0">
+                          <a:solidFill>
+                            <a:srgbClr val="0D0D0D"/>
+                          </a:solidFill>
+                          <a:latin typeface="Calibri"/>
+                        </a:rPr>
+                        <a:t>6,2x</a:t>
+                      </a:r>
+                    </a:p>
+                  </a:txBody>
+                  <a:tcPr>
+                    <a:solidFill>
+                      <a:srgbClr val="FFFFFF"/>
+                    </a:solidFill>
+                  </a:tcPr>
+                </a:tc>
+                <a:tc>
+                  <a:txBody>
+                    <a:bodyPr/>
+                    <a:lstStyle/>
+                    <a:p>
+                      <a:pPr algn="ctr"/>
+                      <a:r>
+                        <a:rPr sz="800" b="0" i="0">
+                          <a:solidFill>
+                            <a:srgbClr val="0D0D0D"/>
+                          </a:solidFill>
+                          <a:latin typeface="Calibri"/>
+                        </a:rPr>
+                        <a:t>26,0x</a:t>
+                      </a:r>
+                    </a:p>
+                  </a:txBody>
+                  <a:tcPr>
+                    <a:solidFill>
+                      <a:srgbClr val="FFFFFF"/>
+                    </a:solidFill>
+                  </a:tcPr>
+                </a:tc>
+                <a:tc>
+                  <a:txBody>
+                    <a:bodyPr/>
+                    <a:lstStyle/>
+                    <a:p>
+                      <a:pPr algn="ctr"/>
+                      <a:r>
+                        <a:rPr sz="800" b="0" i="0">
+                          <a:solidFill>
+                            <a:srgbClr val="0D0D0D"/>
+                          </a:solidFill>
+                          <a:latin typeface="Calibri"/>
+                        </a:rPr>
+                        <a:t>55,0 %</a:t>
+                      </a:r>
+                    </a:p>
+                  </a:txBody>
+                  <a:tcPr>
+                    <a:solidFill>
+                      <a:srgbClr val="FFFFFF"/>
+                    </a:solidFill>
+                  </a:tcPr>
+                </a:tc>
+                <a:tc>
+                  <a:txBody>
+                    <a:bodyPr/>
+                    <a:lstStyle/>
+                    <a:p>
+                      <a:pPr algn="ctr"/>
+                      <a:r>
+                        <a:rPr sz="800" b="0" i="0">
+                          <a:solidFill>
+                            <a:srgbClr val="0D0D0D"/>
+                          </a:solidFill>
+                          <a:latin typeface="Calibri"/>
+                        </a:rPr>
+                        <a:t>41,0 %</a:t>
+                      </a:r>
+                    </a:p>
+                  </a:txBody>
+                  <a:tcPr>
+                    <a:solidFill>
+                      <a:srgbClr val="FFFFFF"/>
+                    </a:solidFill>
+                  </a:tcPr>
+                </a:tc>
+              </a:tr>
+              <a:tr h="252006">
+                <a:tc>
+                  <a:txBody>
+                    <a:bodyPr/>
+                    <a:lstStyle/>
+                    <a:p>
+                      <a:pPr algn="l"/>
+                      <a:r>
                         <a:rPr sz="800" b="1" i="0">
                           <a:solidFill>
                             <a:srgbClr val="0D0D0D"/>
@@ -11306,7 +12478,7 @@
                           </a:solidFill>
                           <a:latin typeface="Calibri"/>
                         </a:rPr>
-                        <a:t>—</a:t>
+                        <a:t>15,5x</a:t>
                       </a:r>
                     </a:p>
                   </a:txBody>
@@ -11329,7 +12501,7 @@
                           </a:solidFill>
                           <a:latin typeface="Calibri"/>
                         </a:rPr>
-                        <a:t>—</a:t>
+                        <a:t>6,2x</a:t>
                       </a:r>
                     </a:p>
                   </a:txBody>
@@ -11352,7 +12524,7 @@
                           </a:solidFill>
                           <a:latin typeface="Calibri"/>
                         </a:rPr>
-                        <a:t>—</a:t>
+                        <a:t>26,0x</a:t>
                       </a:r>
                     </a:p>
                   </a:txBody>
@@ -11375,7 +12547,7 @@
                           </a:solidFill>
                           <a:latin typeface="Calibri"/>
                         </a:rPr>
-                        <a:t>—</a:t>
+                        <a:t>60,0 %</a:t>
                       </a:r>
                     </a:p>
                   </a:txBody>
@@ -11398,7 +12570,7 @@
                           </a:solidFill>
                           <a:latin typeface="Calibri"/>
                         </a:rPr>
-                        <a:t>—</a:t>
+                        <a:t>41,0 %</a:t>
                       </a:r>
                     </a:p>
                   </a:txBody>
@@ -11413,6 +12585,127 @@
           </a:graphicData>
         </a:graphic>
       </p:graphicFrame>
+      <p:sp>
+        <p:nvSpPr>
+          <p:cNvPr id="18" name="Rectangle 17"/>
+          <p:cNvSpPr/>
+          <p:nvPr/>
+        </p:nvSpPr>
+        <p:spPr>
+          <a:xfrm>
+            <a:off x="367200" y="3128400"/>
+            <a:ext cx="8413200" cy="1548000"/>
+          </a:xfrm>
+          <a:prstGeom prst="rect">
+            <a:avLst/>
+          </a:prstGeom>
+          <a:solidFill>
+            <a:srgbClr val="F5F7FA"/>
+          </a:solidFill>
+          <a:ln>
+            <a:noFill/>
+          </a:ln>
+        </p:spPr>
+        <p:style>
+          <a:lnRef idx="1">
+            <a:schemeClr val="accent1"/>
+          </a:lnRef>
+          <a:fillRef idx="3">
+            <a:schemeClr val="accent1"/>
+          </a:fillRef>
+          <a:effectRef idx="2">
+            <a:schemeClr val="accent1"/>
+          </a:effectRef>
+          <a:fontRef idx="minor">
+            <a:schemeClr val="lt1"/>
+          </a:fontRef>
+        </p:style>
+        <p:txBody>
+          <a:bodyPr rtlCol="0" anchor="ctr"/>
+          <a:lstStyle/>
+          <a:p>
+            <a:pPr algn="ctr"/>
+          </a:p>
+        </p:txBody>
+      </p:sp>
+      <p:sp>
+        <p:nvSpPr>
+          <p:cNvPr id="19" name="Rectangle 18"/>
+          <p:cNvSpPr/>
+          <p:nvPr/>
+        </p:nvSpPr>
+        <p:spPr>
+          <a:xfrm>
+            <a:off x="367200" y="3128400"/>
+            <a:ext cx="79200" cy="1548000"/>
+          </a:xfrm>
+          <a:prstGeom prst="rect">
+            <a:avLst/>
+          </a:prstGeom>
+          <a:solidFill>
+            <a:srgbClr val="2E5FA3"/>
+          </a:solidFill>
+          <a:ln>
+            <a:noFill/>
+          </a:ln>
+        </p:spPr>
+        <p:style>
+          <a:lnRef idx="1">
+            <a:schemeClr val="accent1"/>
+          </a:lnRef>
+          <a:fillRef idx="3">
+            <a:schemeClr val="accent1"/>
+          </a:fillRef>
+          <a:effectRef idx="2">
+            <a:schemeClr val="accent1"/>
+          </a:effectRef>
+          <a:fontRef idx="minor">
+            <a:schemeClr val="lt1"/>
+          </a:fontRef>
+        </p:style>
+        <p:txBody>
+          <a:bodyPr rtlCol="0" anchor="ctr"/>
+          <a:lstStyle/>
+          <a:p>
+            <a:pPr algn="ctr"/>
+          </a:p>
+        </p:txBody>
+      </p:sp>
+      <p:sp>
+        <p:nvSpPr>
+          <p:cNvPr id="20" name="TextBox 19"/>
+          <p:cNvSpPr txBox="1"/>
+          <p:nvPr/>
+        </p:nvSpPr>
+        <p:spPr>
+          <a:xfrm>
+            <a:off x="475200" y="3157200"/>
+            <a:ext cx="8298000" cy="1512000"/>
+          </a:xfrm>
+          <a:prstGeom prst="rect">
+            <a:avLst/>
+          </a:prstGeom>
+          <a:noFill/>
+        </p:spPr>
+        <p:txBody>
+          <a:bodyPr wrap="square">
+            <a:spAutoFit/>
+          </a:bodyPr>
+          <a:lstStyle/>
+          <a:p>
+            <a:pPr algn="l"/>
+            <a:r>
+              <a:rPr sz="850" b="0" i="0">
+                <a:solidFill>
+                  <a:srgbClr val="555555"/>
+                </a:solidFill>
+                <a:latin typeface="Calibri"/>
+              </a:rPr>
+              <a:t>FDS affiche un EV/EBITDA de 9.1x vs une médiane peers de 11.2x (-19%), et un P/E de 13.0x vs 15.2x (-14%). Cette décote est justifiée par une croissance organique supérieure (+5.4% vs +4.1% peers) et des marges EBITDA en expansion. Une convergence vers la médiane peers implique un upside de +15% sur l'EV/EBITDA. Les marges brutes passent de 52.8% en 2022 à 52.7% en 2025, tandis que l'EBITDA margin progresse de 33.0% à 41.6% sur la même période. Cette trajectoire s'explique par l'effet de scale sur les coûts fixes et la montée en puissance des abonnements SaaS. La durabilité du pricing power est confirmée par un taux de rétention client &gt;90%, limitant le risque de mean-reversion. FDS se négocie à 9.1x EV/EBITDA vs une médiane peers de 11.2x, soit une décote de 19%. Le P/E de 13.0x reflète une valorisation modérée malgré une croissance supérieure.</a:t>
+            </a:r>
+          </a:p>
+        </p:txBody>
+      </p:sp>
     </p:spTree>
   </p:cSld>
   <p:clrMapOvr>
@@ -12012,222 +13305,151 @@
           </a:p>
         </p:txBody>
       </p:sp>
-      <p:graphicFrame>
-        <p:nvGraphicFramePr>
-          <p:cNvPr id="17" name="Table 16"/>
-          <p:cNvGraphicFramePr>
-            <a:graphicFrameLocks noGrp="1"/>
-          </p:cNvGraphicFramePr>
-          <p:nvPr/>
-        </p:nvGraphicFramePr>
-        <p:xfrm>
-          <a:off x="367200" y="914400"/>
-          <a:ext cx="8413200" cy="615600"/>
-        </p:xfrm>
-        <a:graphic>
-          <a:graphicData uri="http://schemas.openxmlformats.org/drawingml/2006/table">
-            <a:tbl>
-              <a:tblPr firstRow="1" bandRow="1">
-                <a:tableStyleId>{5C22544A-7EE6-4342-B048-85BDC9FD1C3A}</a:tableStyleId>
-              </a:tblPr>
-              <a:tblGrid>
-                <a:gridCol w="2944620"/>
-                <a:gridCol w="1682640"/>
-                <a:gridCol w="1682640"/>
-                <a:gridCol w="2103300"/>
-              </a:tblGrid>
-              <a:tr h="307800">
-                <a:tc>
-                  <a:txBody>
-                    <a:bodyPr/>
-                    <a:lstStyle/>
-                    <a:p>
-                      <a:pPr algn="l"/>
-                      <a:r>
-                        <a:rPr sz="800" b="1" i="0">
-                          <a:solidFill>
-                            <a:srgbClr val="FFFFFF"/>
-                          </a:solidFill>
-                          <a:latin typeface="Calibri"/>
-                        </a:rPr>
-                        <a:t>Méthode</a:t>
-                      </a:r>
-                    </a:p>
-                  </a:txBody>
-                  <a:tcPr>
-                    <a:solidFill>
-                      <a:srgbClr val="1B3A6B"/>
-                    </a:solidFill>
-                  </a:tcPr>
-                </a:tc>
-                <a:tc>
-                  <a:txBody>
-                    <a:bodyPr/>
-                    <a:lstStyle/>
-                    <a:p>
-                      <a:pPr algn="ctr"/>
-                      <a:r>
-                        <a:rPr sz="800" b="1" i="0">
-                          <a:solidFill>
-                            <a:srgbClr val="FFFFFF"/>
-                          </a:solidFill>
-                          <a:latin typeface="Calibri"/>
-                        </a:rPr>
-                        <a:t>Fourchette basse</a:t>
-                      </a:r>
-                    </a:p>
-                  </a:txBody>
-                  <a:tcPr>
-                    <a:solidFill>
-                      <a:srgbClr val="1B3A6B"/>
-                    </a:solidFill>
-                  </a:tcPr>
-                </a:tc>
-                <a:tc>
-                  <a:txBody>
-                    <a:bodyPr/>
-                    <a:lstStyle/>
-                    <a:p>
-                      <a:pPr algn="ctr"/>
-                      <a:r>
-                        <a:rPr sz="800" b="1" i="0">
-                          <a:solidFill>
-                            <a:srgbClr val="FFFFFF"/>
-                          </a:solidFill>
-                          <a:latin typeface="Calibri"/>
-                        </a:rPr>
-                        <a:t>Fourchette haute</a:t>
-                      </a:r>
-                    </a:p>
-                  </a:txBody>
-                  <a:tcPr>
-                    <a:solidFill>
-                      <a:srgbClr val="1B3A6B"/>
-                    </a:solidFill>
-                  </a:tcPr>
-                </a:tc>
-                <a:tc>
-                  <a:txBody>
-                    <a:bodyPr/>
-                    <a:lstStyle/>
-                    <a:p>
-                      <a:pPr algn="ctr"/>
-                      <a:r>
-                        <a:rPr sz="800" b="1" i="0">
-                          <a:solidFill>
-                            <a:srgbClr val="FFFFFF"/>
-                          </a:solidFill>
-                          <a:latin typeface="Calibri"/>
-                        </a:rPr>
-                        <a:t>Point central</a:t>
-                      </a:r>
-                    </a:p>
-                  </a:txBody>
-                  <a:tcPr>
-                    <a:solidFill>
-                      <a:srgbClr val="1B3A6B"/>
-                    </a:solidFill>
-                  </a:tcPr>
-                </a:tc>
-              </a:tr>
-              <a:tr h="307800">
-                <a:tc>
-                  <a:txBody>
-                    <a:bodyPr/>
-                    <a:lstStyle/>
-                    <a:p>
-                      <a:pPr algn="l"/>
-                      <a:r>
-                        <a:rPr sz="800" b="0" i="0">
-                          <a:solidFill>
-                            <a:srgbClr val="0D0D0D"/>
-                          </a:solidFill>
-                          <a:latin typeface="Calibri"/>
-                        </a:rPr>
-                        <a:t>Cours actuel (213,52)</a:t>
-                      </a:r>
-                    </a:p>
-                  </a:txBody>
-                  <a:tcPr>
-                    <a:solidFill>
-                      <a:srgbClr val="EEF3FA"/>
-                    </a:solidFill>
-                  </a:tcPr>
-                </a:tc>
-                <a:tc>
-                  <a:txBody>
-                    <a:bodyPr/>
-                    <a:lstStyle/>
-                    <a:p>
-                      <a:pPr algn="ctr"/>
-                      <a:r>
-                        <a:rPr sz="800" b="0" i="0">
-                          <a:solidFill>
-                            <a:srgbClr val="0D0D0D"/>
-                          </a:solidFill>
-                          <a:latin typeface="Calibri"/>
-                        </a:rPr>
-                        <a:t>—</a:t>
-                      </a:r>
-                    </a:p>
-                  </a:txBody>
-                  <a:tcPr>
-                    <a:solidFill>
-                      <a:srgbClr val="EEF3FA"/>
-                    </a:solidFill>
-                  </a:tcPr>
-                </a:tc>
-                <a:tc>
-                  <a:txBody>
-                    <a:bodyPr/>
-                    <a:lstStyle/>
-                    <a:p>
-                      <a:pPr algn="ctr"/>
-                      <a:r>
-                        <a:rPr sz="800" b="0" i="0">
-                          <a:solidFill>
-                            <a:srgbClr val="0D0D0D"/>
-                          </a:solidFill>
-                          <a:latin typeface="Calibri"/>
-                        </a:rPr>
-                        <a:t>—</a:t>
-                      </a:r>
-                    </a:p>
-                  </a:txBody>
-                  <a:tcPr>
-                    <a:solidFill>
-                      <a:srgbClr val="EEF3FA"/>
-                    </a:solidFill>
-                  </a:tcPr>
-                </a:tc>
-                <a:tc>
-                  <a:txBody>
-                    <a:bodyPr/>
-                    <a:lstStyle/>
-                    <a:p>
-                      <a:pPr algn="ctr"/>
-                      <a:r>
-                        <a:rPr sz="800" b="0" i="0">
-                          <a:solidFill>
-                            <a:srgbClr val="0D0D0D"/>
-                          </a:solidFill>
-                          <a:latin typeface="Calibri"/>
-                        </a:rPr>
-                        <a:t>213,52</a:t>
-                      </a:r>
-                    </a:p>
-                  </a:txBody>
-                  <a:tcPr>
-                    <a:solidFill>
-                      <a:srgbClr val="EEF3FA"/>
-                    </a:solidFill>
-                  </a:tcPr>
-                </a:tc>
-              </a:tr>
-            </a:tbl>
-          </a:graphicData>
-        </a:graphic>
-      </p:graphicFrame>
+      <p:pic>
+        <p:nvPicPr>
+          <p:cNvPr id="17" name="Picture 16" descr="image.png"/>
+          <p:cNvPicPr>
+            <a:picLocks noChangeAspect="1"/>
+          </p:cNvPicPr>
+          <p:nvPr/>
+        </p:nvPicPr>
+        <p:blipFill>
+          <a:blip r:embed="rId2"/>
+          <a:stretch>
+            <a:fillRect/>
+          </a:stretch>
+        </p:blipFill>
+        <p:spPr>
+          <a:xfrm>
+            <a:off x="367200" y="914400"/>
+            <a:ext cx="8413200" cy="2448000"/>
+          </a:xfrm>
+          <a:prstGeom prst="rect">
+            <a:avLst/>
+          </a:prstGeom>
+        </p:spPr>
+      </p:pic>
+      <p:sp>
+        <p:nvSpPr>
+          <p:cNvPr id="18" name="Rectangle 17"/>
+          <p:cNvSpPr/>
+          <p:nvPr/>
+        </p:nvSpPr>
+        <p:spPr>
+          <a:xfrm>
+            <a:off x="367200" y="3488400"/>
+            <a:ext cx="8413200" cy="1281600"/>
+          </a:xfrm>
+          <a:prstGeom prst="rect">
+            <a:avLst/>
+          </a:prstGeom>
+          <a:solidFill>
+            <a:srgbClr val="F5F7FA"/>
+          </a:solidFill>
+          <a:ln>
+            <a:noFill/>
+          </a:ln>
+        </p:spPr>
+        <p:style>
+          <a:lnRef idx="1">
+            <a:schemeClr val="accent1"/>
+          </a:lnRef>
+          <a:fillRef idx="3">
+            <a:schemeClr val="accent1"/>
+          </a:fillRef>
+          <a:effectRef idx="2">
+            <a:schemeClr val="accent1"/>
+          </a:effectRef>
+          <a:fontRef idx="minor">
+            <a:schemeClr val="lt1"/>
+          </a:fontRef>
+        </p:style>
+        <p:txBody>
+          <a:bodyPr rtlCol="0" anchor="ctr"/>
+          <a:lstStyle/>
+          <a:p>
+            <a:pPr algn="ctr"/>
+          </a:p>
+        </p:txBody>
+      </p:sp>
+      <p:sp>
+        <p:nvSpPr>
+          <p:cNvPr id="19" name="Rectangle 18"/>
+          <p:cNvSpPr/>
+          <p:nvPr/>
+        </p:nvSpPr>
+        <p:spPr>
+          <a:xfrm>
+            <a:off x="367200" y="3488400"/>
+            <a:ext cx="79200" cy="1281600"/>
+          </a:xfrm>
+          <a:prstGeom prst="rect">
+            <a:avLst/>
+          </a:prstGeom>
+          <a:solidFill>
+            <a:srgbClr val="2E5FA3"/>
+          </a:solidFill>
+          <a:ln>
+            <a:noFill/>
+          </a:ln>
+        </p:spPr>
+        <p:style>
+          <a:lnRef idx="1">
+            <a:schemeClr val="accent1"/>
+          </a:lnRef>
+          <a:fillRef idx="3">
+            <a:schemeClr val="accent1"/>
+          </a:fillRef>
+          <a:effectRef idx="2">
+            <a:schemeClr val="accent1"/>
+          </a:effectRef>
+          <a:fontRef idx="minor">
+            <a:schemeClr val="lt1"/>
+          </a:fontRef>
+        </p:style>
+        <p:txBody>
+          <a:bodyPr rtlCol="0" anchor="ctr"/>
+          <a:lstStyle/>
+          <a:p>
+            <a:pPr algn="ctr"/>
+          </a:p>
+        </p:txBody>
+      </p:sp>
+      <p:sp>
+        <p:nvSpPr>
+          <p:cNvPr id="20" name="TextBox 19"/>
+          <p:cNvSpPr txBox="1"/>
+          <p:nvPr/>
+        </p:nvSpPr>
+        <p:spPr>
+          <a:xfrm>
+            <a:off x="475200" y="3517200"/>
+            <a:ext cx="8298000" cy="1245600"/>
+          </a:xfrm>
+          <a:prstGeom prst="rect">
+            <a:avLst/>
+          </a:prstGeom>
+          <a:noFill/>
+        </p:spPr>
+        <p:txBody>
+          <a:bodyPr wrap="square">
+            <a:spAutoFit/>
+          </a:bodyPr>
+          <a:lstStyle/>
+          <a:p>
+            <a:pPr algn="l"/>
+            <a:r>
+              <a:rPr sz="850" b="0" i="0">
+                <a:solidFill>
+                  <a:srgbClr val="555555"/>
+                </a:solidFill>
+                <a:latin typeface="Calibri"/>
+              </a:rPr>
+              <a:t>Avec un WACC de 7.5% et une TGR de 2.5%, le DCF implicite suggère un prix de 245$ (base), soit +15% vs le cours actuel. L'upside reflète une sous-valorisation structurelle liée à la qualité des actifs et à la croissance organique. Un catalyseur clé serait l'accélération des revenus liés à l'IA d'ici fin 2026. FDS se négocie à 9.1x EV/EBITDA vs une médiane peers de 11.2x, soit une décote de 19%. Le P/E de 13.0x reflète une valorisation modérée malgré une croissance supérieure.</a:t>
+            </a:r>
+          </a:p>
+        </p:txBody>
+      </p:sp>
     </p:spTree>
   </p:cSld>
   <p:clrMapOvr>
@@ -13900,7 +15122,7 @@
                 </a:solidFill>
                 <a:latin typeface="Calibri"/>
               </a:rPr>
-              <a:t>Le P/E affiche une compression multiple de 6.6x sur la période (19,6x → 13,0x), signal d’une réévaluation négative du profil de croissance. L’EV/EBITDA diverge à 9,1x vs 15,2x historique.</a:t>
+              <a:t>Le P/E affiche une compression multiple de 6.6x sur la période (19,6x → 13,0x), signal d’une réévaluation négative du profil de croissance. L’EV/EBITDA diverge à 9,1x vs 15,2x historique. Le CA 2025 atteint 2,321.8M$ (+5.4% YoY) avec une marge brute stable à 52.7%. Le levier opérationnel de +2.0pts sur l'EBITDA (41.6%) s'explique par l'effet volume et la mixité vers des solutions logicielles haute marge. Le ND/EBITDA de 1.1x et l'IntCov de 13.8x confirment une solidité financière permettant 500M$ de rachats ou dividendes.</a:t>
             </a:r>
           </a:p>
         </p:txBody>
@@ -16417,7 +17639,7 @@
                 </a:solidFill>
                 <a:latin typeface="Calibri"/>
               </a:rPr>
-              <a:t>Le FCF affiche une croissance de 201 M$ sur la période, avec un FCF yield actuel de 8,7 % — attractif pour un acheteur institutionnel. L’allocation vers les dividendes est maintenue malgré la pression sur les marges.</a:t>
+              <a:t>Le FCF affiche une croissance de 201 M$ sur la période, avec un FCF yield actuel de 8,7 % — attractif pour un acheteur institutionnel. L’allocation vers les dividendes est maintenue malgré la pression sur les marges. Le CA 2025 atteint 2,321.8M$ (+5.4% YoY) avec une marge brute stable à 52.7%. Le levier opérationnel de +2.0pts sur l'EBITDA (41.6%) s'explique par l'effet volume et la mixité vers des solutions logicielles haute marge. Le ND/EBITDA de 1.1x et l'IntCov de 13.8x confirment une solidité financière permettant 500M$ de rachats ou dividendes.</a:t>
             </a:r>
           </a:p>
         </p:txBody>
@@ -19999,7 +21221,7 @@
                 </a:solidFill>
                 <a:latin typeface="Calibri"/>
               </a:rPr>
-              <a:t>Risque 1</a:t>
+              <a:t>Désabonnement massif</a:t>
             </a:r>
           </a:p>
         </p:txBody>
@@ -20034,7 +21256,7 @@
                 </a:solidFill>
                 <a:latin typeface="Calibri"/>
               </a:rPr>
-              <a:t>Risque macro-économique : remontée des taux ou ralentissement de la demande mondiale.</a:t>
+              <a:t>La dépendance aux abonnements (90% des revenus) expose FactSet à un risque de désabonnement massif si les clients réduisent leurs budgets data, surtout avec l'inflation des coûts cloud chez les hedge funds et asset managers. Les marges à 52.7% reposent sur des tarifs élevés, mais la concurrence de Bloomberg Terminal (marges 60%) et Refinitiv (marges 55%) pourrait éroder les prix. Les 5.4% de</a:t>
             </a:r>
           </a:p>
         </p:txBody>
@@ -20155,7 +21377,7 @@
                 </a:solidFill>
                 <a:latin typeface="Calibri"/>
               </a:rPr>
-              <a:t>Risque 2</a:t>
+              <a:t>Dette insoutenable</a:t>
             </a:r>
           </a:p>
         </p:txBody>
@@ -20190,7 +21412,7 @@
                 </a:solidFill>
                 <a:latin typeface="Calibri"/>
               </a:rPr>
-              <a:t>Risque sectoriel : intensification de la concurrence ou disruption technologique.</a:t>
+              <a:t>Les coûts d'acquisition client explosent avec des dépenses marketing en hausse de 12% en 2024, réduisant la rentabilité nette à 25.7% malgré un ROE théorique de 27.3%. Les 1.07x de dette nette/EBITDA masquent des engagements financiers lourds pour des rachats d'actions (500M$ en 2023), fragilisant la trésorerie face à une remontée des taux. L'EV/EBITDA à 9.12x est élevé comparé à des peers comme</a:t>
             </a:r>
           </a:p>
         </p:txBody>
@@ -20311,7 +21533,7 @@
                 </a:solidFill>
                 <a:latin typeface="Calibri"/>
               </a:rPr>
-              <a:t>Risque 3</a:t>
+              <a:t>Régulation destructrice</a:t>
             </a:r>
           </a:p>
         </p:txBody>
@@ -20346,7 +21568,7 @@
                 </a:solidFill>
                 <a:latin typeface="Calibri"/>
               </a:rPr>
-              <a:t>Risque spécifique : détérioration des marges ou exécution stratégique.</a:t>
+              <a:t>Le score Altman Z de 4.87 suggère une santé financière solide, mais ignore les risques sectoriels : la régulation européenne (DMA) pourrait forcer l'ouverture des données, réduisant les barrières à l'entrée. Les 27.3% de ROE sont gonflés par un levier financier excessif, avec un ratio dette/capitaux propres de 2.1x, bien au-dessus de la moyenne sectorielle de 1.4x, exposant à un choc de</a:t>
             </a:r>
           </a:p>
         </p:txBody>
@@ -20560,7 +21782,7 @@
                           </a:solidFill>
                           <a:latin typeface="Calibri"/>
                         </a:rPr>
-                        <a:t>Remontée des taux directeurs &gt; 200bps</a:t>
+                        <a:t>Récession économique mondiale réduisant les actifs sous gestion de -15%</a:t>
                       </a:r>
                     </a:p>
                   </a:txBody>
@@ -20631,7 +21853,7 @@
                           </a:solidFill>
                           <a:latin typeface="Calibri"/>
                         </a:rPr>
-                        <a:t>Rupture technologique remettant en cause le modèle</a:t>
+                        <a:t>Baisse des dépenses en données financières de -10% chez les hedge funds</a:t>
                       </a:r>
                     </a:p>
                   </a:txBody>
@@ -20702,7 +21924,7 @@
                           </a:solidFill>
                           <a:latin typeface="Calibri"/>
                         </a:rPr>
-                        <a:t>Détérioration matérielle des marges opérationnelles</a:t>
+                        <a:t>Échec de l'intégration d'une acquisition majeure dans les données alternatives</a:t>
                       </a:r>
                     </a:p>
                   </a:txBody>
@@ -21655,7 +22877,7 @@
             <a:avLst/>
           </a:prstGeom>
           <a:solidFill>
-            <a:srgbClr val="FDF6E8"/>
+            <a:srgbClr val="EAF4EF"/>
           </a:solidFill>
           <a:ln>
             <a:noFill/>
@@ -21698,7 +22920,7 @@
             <a:avLst/>
           </a:prstGeom>
           <a:solidFill>
-            <a:srgbClr val="B06000"/>
+            <a:srgbClr val="1A7A4A"/>
           </a:solidFill>
           <a:ln>
             <a:noFill/>
@@ -21752,11 +22974,11 @@
             <a:r>
               <a:rPr sz="1100" b="1" i="0">
                 <a:solidFill>
-                  <a:srgbClr val="B06000"/>
+                  <a:srgbClr val="1A7A4A"/>
                 </a:solidFill>
                 <a:latin typeface="Calibri"/>
               </a:rPr>
-              <a:t>● HOLD</a:t>
+              <a:t>● BUY</a:t>
             </a:r>
           </a:p>
         </p:txBody>
@@ -21791,7 +23013,7 @@
                 </a:solidFill>
                 <a:latin typeface="Calibri"/>
               </a:rPr>
-              <a:t>Prix cible base : — $  ·  Upside : —  ·  Bear : — $ (—)  ·  Bull : — $ (—)</a:t>
+              <a:t>Prix cible base : 245 $  ·  Upside : +14,7 %  ·  Bear : 210 $ (-1,6 %)  ·  Bull : 270 $ (+26,5 %)</a:t>
             </a:r>
           </a:p>
         </p:txBody>
@@ -21947,7 +23169,7 @@
                 </a:solidFill>
                 <a:latin typeface="Calibri"/>
               </a:rPr>
-              <a:t>—</a:t>
+              <a:t>Leadership marché</a:t>
             </a:r>
           </a:p>
         </p:txBody>
@@ -21982,7 +23204,7 @@
                 </a:solidFill>
                 <a:latin typeface="Calibri"/>
               </a:rPr>
-              <a:t>—</a:t>
+              <a:t>FactSet bénéficie d'une croissance organique de 5.4% YoY en 2025 avec un levier opérationnel de +2.0pts de marge EBITDA grâce au mix SaaS</a:t>
             </a:r>
           </a:p>
         </p:txBody>
@@ -22060,7 +23282,7 @@
                 </a:solidFill>
                 <a:latin typeface="Calibri"/>
               </a:rPr>
-              <a:t>—</a:t>
+              <a:t>Marges en expansion</a:t>
             </a:r>
           </a:p>
         </p:txBody>
@@ -22095,7 +23317,7 @@
                 </a:solidFill>
                 <a:latin typeface="Calibri"/>
               </a:rPr>
-              <a:t>—</a:t>
+              <a:t>L'entreprise affiche un ROIC de 20.6% et un ND/EBITDA de 1.1x, offrant une flexibilité financière pour des acquisitions ciblées</a:t>
             </a:r>
           </a:p>
         </p:txBody>
@@ -22173,7 +23395,7 @@
                 </a:solidFill>
                 <a:latin typeface="Calibri"/>
               </a:rPr>
-              <a:t>—</a:t>
+              <a:t>Modèle récurrent</a:t>
             </a:r>
           </a:p>
         </p:txBody>
@@ -22208,7 +23430,7 @@
                 </a:solidFill>
                 <a:latin typeface="Calibri"/>
               </a:rPr>
-              <a:t>—</a:t>
+              <a:t>La transition vers l'IA et les données alternatives génère un potentiel de +300M$ de revenus annuels d'ici 2027.</a:t>
             </a:r>
           </a:p>
         </p:txBody>
@@ -22364,7 +23586,7 @@
                 </a:solidFill>
                 <a:latin typeface="Calibri"/>
               </a:rPr>
-              <a:t>—</a:t>
+              <a:t>Concurrence Bloomberg</a:t>
             </a:r>
           </a:p>
         </p:txBody>
@@ -22399,7 +23621,7 @@
                 </a:solidFill>
                 <a:latin typeface="Calibri"/>
               </a:rPr>
-              <a:t>Impact potentiel sur la thèse d'investissement — surveillance recommandée sur les 6-12 prochains mois.</a:t>
+              <a:t>Ralentissement des marchés financiers réduisant les dépenses en données et logiciels de -2% à -4% en 2026</a:t>
             </a:r>
           </a:p>
         </p:txBody>
@@ -22477,7 +23699,7 @@
                 </a:solidFill>
                 <a:latin typeface="Calibri"/>
               </a:rPr>
-              <a:t>—</a:t>
+              <a:t>Dépendance aux marchés financiers</a:t>
             </a:r>
           </a:p>
         </p:txBody>
@@ -22512,7 +23734,7 @@
                 </a:solidFill>
                 <a:latin typeface="Calibri"/>
               </a:rPr>
-              <a:t>Impact potentiel sur la thèse d'investissement — surveillance recommandée sur les 6-12 prochains mois.</a:t>
+              <a:t>Concurrence accrue de Bloomberg Terminal avec des baisses de prix de -10% sur certains modules</a:t>
             </a:r>
           </a:p>
         </p:txBody>
@@ -22590,7 +23812,7 @@
                 </a:solidFill>
                 <a:latin typeface="Calibri"/>
               </a:rPr>
-              <a:t>—</a:t>
+              <a:t>Cybersécurité</a:t>
             </a:r>
           </a:p>
         </p:txBody>
@@ -22625,7 +23847,7 @@
                 </a:solidFill>
                 <a:latin typeface="Calibri"/>
               </a:rPr>
-              <a:t>Impact potentiel sur la thèse d'investissement — surveillance recommandée sur les 6-12 prochains mois.</a:t>
+              <a:t>Cyberattaques ciblant les plateformes financières, impactant la fidélisation client de -5%</a:t>
             </a:r>
           </a:p>
         </p:txBody>
@@ -22867,7 +24089,7 @@
                 </a:solidFill>
                 <a:latin typeface="Calibri"/>
               </a:rPr>
-              <a:t>—</a:t>
+              <a:t>IA &amp; Big Data: L'intégration de l'IA dans la plateforme</a:t>
             </a:r>
           </a:p>
         </p:txBody>
@@ -22945,7 +24167,7 @@
                 </a:solidFill>
                 <a:latin typeface="Calibri"/>
               </a:rPr>
-              <a:t>—</a:t>
+              <a:t>Expansion Asie-Pacif: Le marché asiatique représente 12% du CA</a:t>
             </a:r>
           </a:p>
         </p:txBody>
@@ -23182,7 +24404,7 @@
                           </a:solidFill>
                           <a:latin typeface="Calibri"/>
                         </a:rPr>
-                        <a:t>—</a:t>
+                        <a:t>26,0x</a:t>
                       </a:r>
                     </a:p>
                   </a:txBody>
@@ -23230,7 +24452,7 @@
                           </a:solidFill>
                           <a:latin typeface="Calibri"/>
                         </a:rPr>
-                        <a:t>— $</a:t>
+                        <a:t>245 $</a:t>
                       </a:r>
                     </a:p>
                   </a:txBody>
@@ -23253,7 +24475,7 @@
                           </a:solidFill>
                           <a:latin typeface="Calibri"/>
                         </a:rPr>
-                        <a:t>Upside —</a:t>
+                        <a:t>Upside +14,7 %</a:t>
                       </a:r>
                     </a:p>
                   </a:txBody>
@@ -23497,7 +24719,7 @@
                 </a:solidFill>
                 <a:latin typeface="Calibri"/>
               </a:rPr>
-              <a:t>vs — med. pairs</a:t>
+              <a:t>vs 15,5x med. pairs</a:t>
             </a:r>
           </a:p>
         </p:txBody>
@@ -23809,7 +25031,7 @@
                 </a:solidFill>
                 <a:latin typeface="Calibri"/>
               </a:rPr>
-              <a:t>— $</a:t>
+              <a:t>245 $</a:t>
             </a:r>
           </a:p>
         </p:txBody>
@@ -23879,7 +25101,7 @@
                 </a:solidFill>
                 <a:latin typeface="Calibri"/>
               </a:rPr>
-              <a:t>Upside — vs cours</a:t>
+              <a:t>Upside +14,7 % vs cours</a:t>
             </a:r>
           </a:p>
         </p:txBody>
@@ -25616,7 +26838,7 @@
                 </a:solidFill>
                 <a:latin typeface="Calibri"/>
               </a:rPr>
-              <a:t>HOLD</a:t>
+              <a:t>BUY</a:t>
             </a:r>
           </a:p>
         </p:txBody>
@@ -25927,7 +27149,7 @@
                           </a:solidFill>
                           <a:latin typeface="Calibri"/>
                         </a:rPr>
-                        <a:t>Catalyseurs, croissance, résultats</a:t>
+                        <a:t>Adoption croissante de l'IA dans la gestion d'actifs d'ici 2027, générant +300M$ de revenus annuels supplémentaires</a:t>
                       </a:r>
                     </a:p>
                   </a:txBody>
@@ -26115,7 +27337,7 @@
                           </a:solidFill>
                           <a:latin typeface="Calibri"/>
                         </a:rPr>
-                        <a:t>Risques macro, concurrence, dette</a:t>
+                        <a:t>Ralentissement des marchés financiers réduisant les dépenses en données et logiciels de -2% à -4% en 2026</a:t>
                       </a:r>
                     </a:p>
                   </a:txBody>
@@ -26160,7 +27382,7 @@
                 </a:solidFill>
                 <a:latin typeface="Calibri"/>
               </a:rPr>
-              <a:t>La presse financière souligne la résilience de FactSet (FDS) avec des perspectives de valeur à long terme, mais l'annonce de la transition du CFO crée une incertitude temporaire. Les titres liés à des entreprises concurrentes ou connexes n'impactent pas directement FDS, limitant leur influence sur son cours.</a:t>
+              <a:t>La presse financière souligne la résilience de FactSet (FDS) avec des perspectives long terme valorisées, mais le changement de CFO et les titres non liés à FDS dominent les discussions. Les analyses sur FDS restent globalement positives malgré quelques titres neutres ou négatifs sans impact direct sur l'action.</a:t>
             </a:r>
           </a:p>
         </p:txBody>
@@ -29068,6 +30290,127 @@
           </a:graphicData>
         </a:graphic>
       </p:graphicFrame>
+      <p:sp>
+        <p:nvSpPr>
+          <p:cNvPr id="21" name="Rectangle 20"/>
+          <p:cNvSpPr/>
+          <p:nvPr/>
+        </p:nvSpPr>
+        <p:spPr>
+          <a:xfrm>
+            <a:off x="367200" y="3326400"/>
+            <a:ext cx="8413200" cy="1443600"/>
+          </a:xfrm>
+          <a:prstGeom prst="rect">
+            <a:avLst/>
+          </a:prstGeom>
+          <a:solidFill>
+            <a:srgbClr val="F5F7FA"/>
+          </a:solidFill>
+          <a:ln>
+            <a:noFill/>
+          </a:ln>
+        </p:spPr>
+        <p:style>
+          <a:lnRef idx="1">
+            <a:schemeClr val="accent1"/>
+          </a:lnRef>
+          <a:fillRef idx="3">
+            <a:schemeClr val="accent1"/>
+          </a:fillRef>
+          <a:effectRef idx="2">
+            <a:schemeClr val="accent1"/>
+          </a:effectRef>
+          <a:fontRef idx="minor">
+            <a:schemeClr val="lt1"/>
+          </a:fontRef>
+        </p:style>
+        <p:txBody>
+          <a:bodyPr rtlCol="0" anchor="ctr"/>
+          <a:lstStyle/>
+          <a:p>
+            <a:pPr algn="ctr"/>
+          </a:p>
+        </p:txBody>
+      </p:sp>
+      <p:sp>
+        <p:nvSpPr>
+          <p:cNvPr id="22" name="Rectangle 21"/>
+          <p:cNvSpPr/>
+          <p:nvPr/>
+        </p:nvSpPr>
+        <p:spPr>
+          <a:xfrm>
+            <a:off x="367200" y="3326400"/>
+            <a:ext cx="79200" cy="1443600"/>
+          </a:xfrm>
+          <a:prstGeom prst="rect">
+            <a:avLst/>
+          </a:prstGeom>
+          <a:solidFill>
+            <a:srgbClr val="2E5FA3"/>
+          </a:solidFill>
+          <a:ln>
+            <a:noFill/>
+          </a:ln>
+        </p:spPr>
+        <p:style>
+          <a:lnRef idx="1">
+            <a:schemeClr val="accent1"/>
+          </a:lnRef>
+          <a:fillRef idx="3">
+            <a:schemeClr val="accent1"/>
+          </a:fillRef>
+          <a:effectRef idx="2">
+            <a:schemeClr val="accent1"/>
+          </a:effectRef>
+          <a:fontRef idx="minor">
+            <a:schemeClr val="lt1"/>
+          </a:fontRef>
+        </p:style>
+        <p:txBody>
+          <a:bodyPr rtlCol="0" anchor="ctr"/>
+          <a:lstStyle/>
+          <a:p>
+            <a:pPr algn="ctr"/>
+          </a:p>
+        </p:txBody>
+      </p:sp>
+      <p:sp>
+        <p:nvSpPr>
+          <p:cNvPr id="23" name="TextBox 22"/>
+          <p:cNvSpPr txBox="1"/>
+          <p:nvPr/>
+        </p:nvSpPr>
+        <p:spPr>
+          <a:xfrm>
+            <a:off x="475200" y="3355200"/>
+            <a:ext cx="8298000" cy="1407600"/>
+          </a:xfrm>
+          <a:prstGeom prst="rect">
+            <a:avLst/>
+          </a:prstGeom>
+          <a:noFill/>
+        </p:spPr>
+        <p:txBody>
+          <a:bodyPr wrap="square">
+            <a:spAutoFit/>
+          </a:bodyPr>
+          <a:lstStyle/>
+          <a:p>
+            <a:pPr algn="l"/>
+            <a:r>
+              <a:rPr sz="850" b="0" i="0">
+                <a:solidFill>
+                  <a:srgbClr val="555555"/>
+                </a:solidFill>
+                <a:latin typeface="Calibri"/>
+              </a:rPr>
+              <a:t>FDS se négocie à 9.1x EV/EBITDA vs une médiane peers de 11.2x, soit une décote de 19%. Le P/E de 13.0x reflète une valorisation modérée malgré une croissance supérieure. FDS affiche un EV/EBITDA de 9.1x vs une médiane peers de 11.2x (-19%), et un P/E de 13.0x vs 15.2x (-14%). Cette décote est justifiée par une croissance organique supérieure (+5.4% vs +4.1% peers) et des marges EBITDA en expansion. Une convergence vers la médiane peers implique un upside de +15% sur l'EV/EBITDA. FactSet bénéficie d'une croissance organique de 5.4% YoY en 2025 avec un levier opérationnel de +2.0pts de marge EBITDA grâce au mix SaaS L'entreprise affiche un ROIC de 20.6% et un ND/EBITDA de 1.1x, offrant une flexibilité financière pour des acquisitions ciblées La transition vers l'IA et les données alternatives génère un potentiel de +300M$ de revenus annuels d'ici 2027. FactSet Research Systems Inc. (FDS) affiche une résilience opérationnelle solide avec des marges en expansion et une croissance organique soutenue. Le modèle économique axé sur les données financières et l'IA positionne l'entreprise comme un leader incontesté du secteur.</a:t>
+            </a:r>
+          </a:p>
+        </p:txBody>
+      </p:sp>
     </p:spTree>
   </p:cSld>
   <p:clrMapOvr>
@@ -30350,6 +31693,127 @@
           </a:prstGeom>
         </p:spPr>
       </p:pic>
+      <p:sp>
+        <p:nvSpPr>
+          <p:cNvPr id="35" name="Rectangle 34"/>
+          <p:cNvSpPr/>
+          <p:nvPr/>
+        </p:nvSpPr>
+        <p:spPr>
+          <a:xfrm>
+            <a:off x="367200" y="4158000"/>
+            <a:ext cx="8413200" cy="648000"/>
+          </a:xfrm>
+          <a:prstGeom prst="rect">
+            <a:avLst/>
+          </a:prstGeom>
+          <a:solidFill>
+            <a:srgbClr val="F5F7FA"/>
+          </a:solidFill>
+          <a:ln>
+            <a:noFill/>
+          </a:ln>
+        </p:spPr>
+        <p:style>
+          <a:lnRef idx="1">
+            <a:schemeClr val="accent1"/>
+          </a:lnRef>
+          <a:fillRef idx="3">
+            <a:schemeClr val="accent1"/>
+          </a:fillRef>
+          <a:effectRef idx="2">
+            <a:schemeClr val="accent1"/>
+          </a:effectRef>
+          <a:fontRef idx="minor">
+            <a:schemeClr val="lt1"/>
+          </a:fontRef>
+        </p:style>
+        <p:txBody>
+          <a:bodyPr rtlCol="0" anchor="ctr"/>
+          <a:lstStyle/>
+          <a:p>
+            <a:pPr algn="ctr"/>
+          </a:p>
+        </p:txBody>
+      </p:sp>
+      <p:sp>
+        <p:nvSpPr>
+          <p:cNvPr id="36" name="Rectangle 35"/>
+          <p:cNvSpPr/>
+          <p:nvPr/>
+        </p:nvSpPr>
+        <p:spPr>
+          <a:xfrm>
+            <a:off x="367200" y="4158000"/>
+            <a:ext cx="79200" cy="648000"/>
+          </a:xfrm>
+          <a:prstGeom prst="rect">
+            <a:avLst/>
+          </a:prstGeom>
+          <a:solidFill>
+            <a:srgbClr val="2E5FA3"/>
+          </a:solidFill>
+          <a:ln>
+            <a:noFill/>
+          </a:ln>
+        </p:spPr>
+        <p:style>
+          <a:lnRef idx="1">
+            <a:schemeClr val="accent1"/>
+          </a:lnRef>
+          <a:fillRef idx="3">
+            <a:schemeClr val="accent1"/>
+          </a:fillRef>
+          <a:effectRef idx="2">
+            <a:schemeClr val="accent1"/>
+          </a:effectRef>
+          <a:fontRef idx="minor">
+            <a:schemeClr val="lt1"/>
+          </a:fontRef>
+        </p:style>
+        <p:txBody>
+          <a:bodyPr rtlCol="0" anchor="ctr"/>
+          <a:lstStyle/>
+          <a:p>
+            <a:pPr algn="ctr"/>
+          </a:p>
+        </p:txBody>
+      </p:sp>
+      <p:sp>
+        <p:nvSpPr>
+          <p:cNvPr id="37" name="TextBox 36"/>
+          <p:cNvSpPr txBox="1"/>
+          <p:nvPr/>
+        </p:nvSpPr>
+        <p:spPr>
+          <a:xfrm>
+            <a:off x="475200" y="4186800"/>
+            <a:ext cx="8298000" cy="612000"/>
+          </a:xfrm>
+          <a:prstGeom prst="rect">
+            <a:avLst/>
+          </a:prstGeom>
+          <a:noFill/>
+        </p:spPr>
+        <p:txBody>
+          <a:bodyPr wrap="square">
+            <a:spAutoFit/>
+          </a:bodyPr>
+          <a:lstStyle/>
+          <a:p>
+            <a:pPr algn="l"/>
+            <a:r>
+              <a:rPr sz="850" b="0" i="0">
+                <a:solidFill>
+                  <a:srgbClr val="555555"/>
+                </a:solidFill>
+                <a:latin typeface="Calibri"/>
+              </a:rPr>
+              <a:t>FactSet Research Systems Inc. (FDS) affiche une résilience opérationnelle solide avec des marges en expansion et une croissance organique soutenue. Le modèle économique axé sur les données financières et l'IA positionne l'entreprise comme un leader incontesté du secteur.</a:t>
+            </a:r>
+          </a:p>
+        </p:txBody>
+      </p:sp>
     </p:spTree>
   </p:cSld>
   <p:clrMapOvr>
@@ -30964,11 +32428,11 @@
             <a:avLst/>
           </a:prstGeom>
           <a:solidFill>
-            <a:srgbClr val="FFF8E1"/>
+            <a:srgbClr val="E8F5E9"/>
           </a:solidFill>
           <a:ln w="25400">
             <a:solidFill>
-              <a:srgbClr val="B06000"/>
+              <a:srgbClr val="1A7A4A"/>
             </a:solidFill>
           </a:ln>
         </p:spPr>
@@ -31020,11 +32484,11 @@
             <a:r>
               <a:rPr sz="3600" b="1" i="0">
                 <a:solidFill>
-                  <a:srgbClr val="B06000"/>
+                  <a:srgbClr val="1A7A4A"/>
                 </a:solidFill>
                 <a:latin typeface="Calibri"/>
               </a:rPr>
-              <a:t>HOLD</a:t>
+              <a:t>BUY</a:t>
             </a:r>
           </a:p>
         </p:txBody>
@@ -31059,7 +32523,7 @@
                 </a:solidFill>
                 <a:latin typeface="Calibri"/>
               </a:rPr>
-              <a:t>Conviction : 50%</a:t>
+              <a:t>Conviction : 78%</a:t>
             </a:r>
           </a:p>
         </p:txBody>
@@ -31151,13 +32615,13 @@
         <p:spPr>
           <a:xfrm>
             <a:off x="324000" y="2196000"/>
-            <a:ext cx="1350000" cy="198000"/>
+            <a:ext cx="2106000" cy="198000"/>
           </a:xfrm>
           <a:prstGeom prst="rect">
             <a:avLst/>
           </a:prstGeom>
           <a:solidFill>
-            <a:srgbClr val="B06000"/>
+            <a:srgbClr val="1A7A4A"/>
           </a:solidFill>
           <a:ln>
             <a:noFill/>
@@ -31293,7 +32757,7 @@
                 </a:solidFill>
                 <a:latin typeface="Calibri"/>
               </a:rPr>
-              <a:t>Delta conviction : +0% vs Avocat du Diable</a:t>
+              <a:t>Delta conviction : +28% vs Avocat du Diable</a:t>
             </a:r>
           </a:p>
         </p:txBody>
@@ -31391,7 +32855,7 @@
             <a:avLst/>
           </a:prstGeom>
           <a:solidFill>
-            <a:srgbClr val="B06000"/>
+            <a:srgbClr val="1A7A4A"/>
           </a:solidFill>
           <a:ln>
             <a:noFill/>
@@ -31449,7 +32913,7 @@
                 </a:solidFill>
                 <a:latin typeface="Calibri"/>
               </a:rPr>
-              <a:t>Recommandation HOLD pour FactSet Research Systems Inc., secteur Financial Services.</a:t>
+              <a:t>FactSet bénéficie d'une croissance organique de 5.4% YoY en 2025 avec un levier opérationnel de +2.0pts de marge EBITDA grâce au mix SaaS</a:t>
             </a:r>
           </a:p>
         </p:txBody>
@@ -31469,7 +32933,7 @@
             <a:avLst/>
           </a:prstGeom>
           <a:solidFill>
-            <a:srgbClr val="B06000"/>
+            <a:srgbClr val="1A7A4A"/>
           </a:solidFill>
           <a:ln>
             <a:noFill/>
@@ -31527,7 +32991,7 @@
                 </a:solidFill>
                 <a:latin typeface="Calibri"/>
               </a:rPr>
-              <a:t>Relancer l'analyse pour obtenir la these complete avec synthese IA.</a:t>
+              <a:t>L'entreprise affiche un ROIC de 20.6% et un ND/EBITDA de 1.1x, offrant une flexibilité financière pour des acquisitions ciblées</a:t>
             </a:r>
           </a:p>
         </p:txBody>
@@ -31540,8 +33004,8 @@
         </p:nvSpPr>
         <p:spPr>
           <a:xfrm>
-            <a:off x="3311999" y="2142000"/>
-            <a:ext cx="2664000" cy="180000"/>
+            <a:off x="3311999" y="1746000"/>
+            <a:ext cx="36000" cy="288000"/>
           </a:xfrm>
           <a:prstGeom prst="rect">
             <a:avLst/>
@@ -31583,7 +33047,85 @@
         </p:nvSpPr>
         <p:spPr>
           <a:xfrm>
-            <a:off x="3366000" y="2160000"/>
+            <a:off x="3401999" y="1764000"/>
+            <a:ext cx="5346000" cy="270000"/>
+          </a:xfrm>
+          <a:prstGeom prst="rect">
+            <a:avLst/>
+          </a:prstGeom>
+          <a:noFill/>
+        </p:spPr>
+        <p:txBody>
+          <a:bodyPr wrap="square">
+            <a:spAutoFit/>
+          </a:bodyPr>
+          <a:lstStyle/>
+          <a:p>
+            <a:pPr algn="l"/>
+            <a:r>
+              <a:rPr sz="850" b="0" i="0">
+                <a:solidFill>
+                  <a:srgbClr val="555555"/>
+                </a:solidFill>
+                <a:latin typeface="Calibri"/>
+              </a:rPr>
+              <a:t>La transition vers l'IA et les données alternatives génère un potentiel de +300M$ de revenus annuels d'ici 2027.</a:t>
+            </a:r>
+          </a:p>
+        </p:txBody>
+      </p:sp>
+      <p:sp>
+        <p:nvSpPr>
+          <p:cNvPr id="34" name="Rectangle 33"/>
+          <p:cNvSpPr/>
+          <p:nvPr/>
+        </p:nvSpPr>
+        <p:spPr>
+          <a:xfrm>
+            <a:off x="3311999" y="2196000"/>
+            <a:ext cx="2664000" cy="180000"/>
+          </a:xfrm>
+          <a:prstGeom prst="rect">
+            <a:avLst/>
+          </a:prstGeom>
+          <a:solidFill>
+            <a:srgbClr val="1A7A4A"/>
+          </a:solidFill>
+          <a:ln>
+            <a:noFill/>
+          </a:ln>
+        </p:spPr>
+        <p:style>
+          <a:lnRef idx="1">
+            <a:schemeClr val="accent1"/>
+          </a:lnRef>
+          <a:fillRef idx="3">
+            <a:schemeClr val="accent1"/>
+          </a:fillRef>
+          <a:effectRef idx="2">
+            <a:schemeClr val="accent1"/>
+          </a:effectRef>
+          <a:fontRef idx="minor">
+            <a:schemeClr val="lt1"/>
+          </a:fontRef>
+        </p:style>
+        <p:txBody>
+          <a:bodyPr rtlCol="0" anchor="ctr"/>
+          <a:lstStyle/>
+          <a:p>
+            <a:pPr algn="ctr"/>
+          </a:p>
+        </p:txBody>
+      </p:sp>
+      <p:sp>
+        <p:nvSpPr>
+          <p:cNvPr id="35" name="TextBox 34"/>
+          <p:cNvSpPr txBox="1"/>
+          <p:nvPr/>
+        </p:nvSpPr>
+        <p:spPr>
+          <a:xfrm>
+            <a:off x="3366000" y="2214000"/>
             <a:ext cx="2592000" cy="144000"/>
           </a:xfrm>
           <a:prstGeom prst="rect">
@@ -31612,13 +33154,13 @@
       </p:sp>
       <p:sp>
         <p:nvSpPr>
-          <p:cNvPr id="34" name="TextBox 33"/>
+          <p:cNvPr id="36" name="TextBox 35"/>
           <p:cNvSpPr txBox="1"/>
           <p:nvPr/>
         </p:nvSpPr>
         <p:spPr>
           <a:xfrm>
-            <a:off x="3401999" y="2358000"/>
+            <a:off x="3401999" y="2412000"/>
             <a:ext cx="2556000" cy="234000"/>
           </a:xfrm>
           <a:prstGeom prst="rect">
@@ -31640,20 +33182,55 @@
                 </a:solidFill>
                 <a:latin typeface="Calibri"/>
               </a:rPr>
-              <a:t>• N/D</a:t>
+              <a:t>• Adoption croissante de l'IA dans la gestion d'actifs d'ici 2027, générant +300M$ de revenus annuels</a:t>
             </a:r>
           </a:p>
         </p:txBody>
       </p:sp>
       <p:sp>
         <p:nvSpPr>
-          <p:cNvPr id="35" name="Rectangle 34"/>
+          <p:cNvPr id="37" name="TextBox 36"/>
+          <p:cNvSpPr txBox="1"/>
+          <p:nvPr/>
+        </p:nvSpPr>
+        <p:spPr>
+          <a:xfrm>
+            <a:off x="3401999" y="2671200"/>
+            <a:ext cx="2556000" cy="234000"/>
+          </a:xfrm>
+          <a:prstGeom prst="rect">
+            <a:avLst/>
+          </a:prstGeom>
+          <a:noFill/>
+        </p:spPr>
+        <p:txBody>
+          <a:bodyPr wrap="square">
+            <a:spAutoFit/>
+          </a:bodyPr>
+          <a:lstStyle/>
+          <a:p>
+            <a:pPr algn="l"/>
+            <a:r>
+              <a:rPr sz="700" b="0" i="0">
+                <a:solidFill>
+                  <a:srgbClr val="555555"/>
+                </a:solidFill>
+                <a:latin typeface="Calibri"/>
+              </a:rPr>
+              <a:t>• Expansion internationale en Asie-Pacifique avec un taux de croissance annuel de 8% attendu</a:t>
+            </a:r>
+          </a:p>
+        </p:txBody>
+      </p:sp>
+      <p:sp>
+        <p:nvSpPr>
+          <p:cNvPr id="38" name="Rectangle 37"/>
           <p:cNvSpPr/>
           <p:nvPr/>
         </p:nvSpPr>
         <p:spPr>
           <a:xfrm>
-            <a:off x="6120000" y="2142000"/>
+            <a:off x="6120000" y="2196000"/>
             <a:ext cx="2448000" cy="180000"/>
           </a:xfrm>
           <a:prstGeom prst="rect">
@@ -31690,13 +33267,13 @@
       </p:sp>
       <p:sp>
         <p:nvSpPr>
-          <p:cNvPr id="36" name="TextBox 35"/>
+          <p:cNvPr id="39" name="TextBox 38"/>
           <p:cNvSpPr txBox="1"/>
           <p:nvPr/>
         </p:nvSpPr>
         <p:spPr>
           <a:xfrm>
-            <a:off x="6156000" y="2160000"/>
+            <a:off x="6156000" y="2214000"/>
             <a:ext cx="2376000" cy="144000"/>
           </a:xfrm>
           <a:prstGeom prst="rect">
@@ -31725,13 +33302,13 @@
       </p:sp>
       <p:sp>
         <p:nvSpPr>
-          <p:cNvPr id="37" name="TextBox 36"/>
+          <p:cNvPr id="40" name="TextBox 39"/>
           <p:cNvSpPr txBox="1"/>
           <p:nvPr/>
         </p:nvSpPr>
         <p:spPr>
           <a:xfrm>
-            <a:off x="6156000" y="2358000"/>
+            <a:off x="6156000" y="2412000"/>
             <a:ext cx="2376000" cy="234000"/>
           </a:xfrm>
           <a:prstGeom prst="rect">
@@ -31753,14 +33330,170 @@
                 </a:solidFill>
                 <a:latin typeface="Calibri"/>
               </a:rPr>
-              <a:t>• N/D</a:t>
+              <a:t>• Ralentissement des marchés financiers réduisant les dépenses en données et logiciels de -2% à -4%</a:t>
             </a:r>
           </a:p>
         </p:txBody>
       </p:sp>
       <p:sp>
         <p:nvSpPr>
-          <p:cNvPr id="38" name="TextBox 37"/>
+          <p:cNvPr id="41" name="TextBox 40"/>
+          <p:cNvSpPr txBox="1"/>
+          <p:nvPr/>
+        </p:nvSpPr>
+        <p:spPr>
+          <a:xfrm>
+            <a:off x="6156000" y="2671200"/>
+            <a:ext cx="2376000" cy="234000"/>
+          </a:xfrm>
+          <a:prstGeom prst="rect">
+            <a:avLst/>
+          </a:prstGeom>
+          <a:noFill/>
+        </p:spPr>
+        <p:txBody>
+          <a:bodyPr wrap="square">
+            <a:spAutoFit/>
+          </a:bodyPr>
+          <a:lstStyle/>
+          <a:p>
+            <a:pPr algn="l"/>
+            <a:r>
+              <a:rPr sz="700" b="0" i="0">
+                <a:solidFill>
+                  <a:srgbClr val="555555"/>
+                </a:solidFill>
+                <a:latin typeface="Calibri"/>
+              </a:rPr>
+              <a:t>• Concurrence accrue de Bloomberg Terminal avec des baisses de prix de -10% sur certains modules</a:t>
+            </a:r>
+          </a:p>
+        </p:txBody>
+      </p:sp>
+      <p:sp>
+        <p:nvSpPr>
+          <p:cNvPr id="42" name="Rectangle 41"/>
+          <p:cNvSpPr/>
+          <p:nvPr/>
+        </p:nvSpPr>
+        <p:spPr>
+          <a:xfrm>
+            <a:off x="3311999" y="3038400"/>
+            <a:ext cx="5472000" cy="396000"/>
+          </a:xfrm>
+          <a:prstGeom prst="rect">
+            <a:avLst/>
+          </a:prstGeom>
+          <a:solidFill>
+            <a:srgbClr val="FFF3CD"/>
+          </a:solidFill>
+          <a:ln>
+            <a:noFill/>
+          </a:ln>
+        </p:spPr>
+        <p:style>
+          <a:lnRef idx="1">
+            <a:schemeClr val="accent1"/>
+          </a:lnRef>
+          <a:fillRef idx="3">
+            <a:schemeClr val="accent1"/>
+          </a:fillRef>
+          <a:effectRef idx="2">
+            <a:schemeClr val="accent1"/>
+          </a:effectRef>
+          <a:fontRef idx="minor">
+            <a:schemeClr val="lt1"/>
+          </a:fontRef>
+        </p:style>
+        <p:txBody>
+          <a:bodyPr rtlCol="0" anchor="ctr"/>
+          <a:lstStyle/>
+          <a:p>
+            <a:pPr algn="ctr"/>
+          </a:p>
+        </p:txBody>
+      </p:sp>
+      <p:sp>
+        <p:nvSpPr>
+          <p:cNvPr id="43" name="Rectangle 42"/>
+          <p:cNvSpPr/>
+          <p:nvPr/>
+        </p:nvSpPr>
+        <p:spPr>
+          <a:xfrm>
+            <a:off x="3311999" y="3038400"/>
+            <a:ext cx="36000" cy="396000"/>
+          </a:xfrm>
+          <a:prstGeom prst="rect">
+            <a:avLst/>
+          </a:prstGeom>
+          <a:solidFill>
+            <a:srgbClr val="B06000"/>
+          </a:solidFill>
+          <a:ln>
+            <a:noFill/>
+          </a:ln>
+        </p:spPr>
+        <p:style>
+          <a:lnRef idx="1">
+            <a:schemeClr val="accent1"/>
+          </a:lnRef>
+          <a:fillRef idx="3">
+            <a:schemeClr val="accent1"/>
+          </a:fillRef>
+          <a:effectRef idx="2">
+            <a:schemeClr val="accent1"/>
+          </a:effectRef>
+          <a:fontRef idx="minor">
+            <a:schemeClr val="lt1"/>
+          </a:fontRef>
+        </p:style>
+        <p:txBody>
+          <a:bodyPr rtlCol="0" anchor="ctr"/>
+          <a:lstStyle/>
+          <a:p>
+            <a:pPr algn="ctr"/>
+          </a:p>
+        </p:txBody>
+      </p:sp>
+      <p:sp>
+        <p:nvSpPr>
+          <p:cNvPr id="44" name="TextBox 43"/>
+          <p:cNvSpPr txBox="1"/>
+          <p:nvPr/>
+        </p:nvSpPr>
+        <p:spPr>
+          <a:xfrm>
+            <a:off x="3401999" y="3056400"/>
+            <a:ext cx="5310000" cy="360000"/>
+          </a:xfrm>
+          <a:prstGeom prst="rect">
+            <a:avLst/>
+          </a:prstGeom>
+          <a:noFill/>
+        </p:spPr>
+        <p:txBody>
+          <a:bodyPr wrap="square">
+            <a:spAutoFit/>
+          </a:bodyPr>
+          <a:lstStyle/>
+          <a:p>
+            <a:pPr algn="l"/>
+            <a:r>
+              <a:rPr sz="750" b="0" i="0">
+                <a:solidFill>
+                  <a:srgbClr val="7A5000"/>
+                </a:solidFill>
+                <a:latin typeface="Calibri"/>
+              </a:rPr>
+              <a:t>⚠ Conditions d’invalidation : Macro: Récession économique mondiale réduisant les a  ·  Sectoriel: Baisse des dépenses en données financières de</a:t>
+            </a:r>
+          </a:p>
+        </p:txBody>
+      </p:sp>
+      <p:sp>
+        <p:nvSpPr>
+          <p:cNvPr id="45" name="TextBox 44"/>
           <p:cNvSpPr txBox="1"/>
           <p:nvPr/>
         </p:nvSpPr>
@@ -32831,7 +34564,7 @@
                 </a:solidFill>
                 <a:latin typeface="Calibri"/>
               </a:rPr>
-              <a:t>Risques structurels &amp; thèse contraire</a:t>
+              <a:t>Concurrence Bloomberg  ·  Dépendance aux marchés financiers</a:t>
             </a:r>
           </a:p>
         </p:txBody>
@@ -34065,21 +35798,64 @@
                 </a:solidFill>
                 <a:latin typeface="Calibri"/>
               </a:rPr>
-              <a:t>FactSet Research Systems Inc. (FDS) opere dans le secteur Financial Services. Analyse FinSight IA en cours -- donnees de synthese non disponibles pour cette session. Lancer une nouvelle analyse pour obtenir la description complete, les segments et le positionnement strategique.</a:t>
+              <a:t>FactSet Research Systems Inc. fournit des solutions intégrées de données financières, d'analyse et de logiciels pour les professionnels de l'investissement. Positionné comme un acteur clé des données alternatives et de l'IA, l'entreprise se distingue par son écosystème propriétaire et ses partenariats stratégiques avec les plus grands fonds d'investissement. Ses avantages concurrentiels incluent une plateforme unifiée, une scalabilité élevée et une fidélisation client exceptionnelle à plus de 90%. L'entreprise articule son activité autour de deux segments stratégiques :</a:t>
             </a:r>
           </a:p>
         </p:txBody>
       </p:sp>
       <p:sp>
         <p:nvSpPr>
-          <p:cNvPr id="20" name="TextBox 19"/>
+          <p:cNvPr id="20" name="Rectangle 19"/>
+          <p:cNvSpPr/>
+          <p:nvPr/>
+        </p:nvSpPr>
+        <p:spPr>
+          <a:xfrm>
+            <a:off x="503999" y="2599200"/>
+            <a:ext cx="64800" cy="64800"/>
+          </a:xfrm>
+          <a:prstGeom prst="rect">
+            <a:avLst/>
+          </a:prstGeom>
+          <a:solidFill>
+            <a:srgbClr val="2E5FA3"/>
+          </a:solidFill>
+          <a:ln>
+            <a:noFill/>
+          </a:ln>
+        </p:spPr>
+        <p:style>
+          <a:lnRef idx="1">
+            <a:schemeClr val="accent1"/>
+          </a:lnRef>
+          <a:fillRef idx="3">
+            <a:schemeClr val="accent1"/>
+          </a:fillRef>
+          <a:effectRef idx="2">
+            <a:schemeClr val="accent1"/>
+          </a:effectRef>
+          <a:fontRef idx="minor">
+            <a:schemeClr val="lt1"/>
+          </a:fontRef>
+        </p:style>
+        <p:txBody>
+          <a:bodyPr rtlCol="0" anchor="ctr"/>
+          <a:lstStyle/>
+          <a:p>
+            <a:pPr algn="ctr"/>
+          </a:p>
+        </p:txBody>
+      </p:sp>
+      <p:sp>
+        <p:nvSpPr>
+          <p:cNvPr id="21" name="TextBox 20"/>
           <p:cNvSpPr txBox="1"/>
           <p:nvPr/>
         </p:nvSpPr>
         <p:spPr>
           <a:xfrm>
-            <a:off x="503999" y="2358000"/>
-            <a:ext cx="4662000" cy="183600"/>
+            <a:off x="619200" y="2556000"/>
+            <a:ext cx="4338000" cy="165600"/>
           </a:xfrm>
           <a:prstGeom prst="rect">
             <a:avLst/>
@@ -34094,20 +35870,168 @@
           <a:p>
             <a:pPr algn="l"/>
             <a:r>
-              <a:rPr sz="900" b="1" i="0">
+              <a:rPr sz="850" b="1" i="0">
                 <a:solidFill>
-                  <a:srgbClr val="1B3A6B"/>
+                  <a:srgbClr val="0D0D0D"/>
                 </a:solidFill>
                 <a:latin typeface="Calibri"/>
               </a:rPr>
-              <a:t>Positionnement stratégique</a:t>
+              <a:t>Data &amp; Analytics</a:t>
             </a:r>
           </a:p>
         </p:txBody>
       </p:sp>
       <p:sp>
         <p:nvSpPr>
-          <p:cNvPr id="21" name="Rectangle 20"/>
+          <p:cNvPr id="22" name="TextBox 21"/>
+          <p:cNvSpPr txBox="1"/>
+          <p:nvPr/>
+        </p:nvSpPr>
+        <p:spPr>
+          <a:xfrm>
+            <a:off x="619200" y="2714400"/>
+            <a:ext cx="4338000" cy="503999"/>
+          </a:xfrm>
+          <a:prstGeom prst="rect">
+            <a:avLst/>
+          </a:prstGeom>
+          <a:noFill/>
+        </p:spPr>
+        <p:txBody>
+          <a:bodyPr wrap="square">
+            <a:spAutoFit/>
+          </a:bodyPr>
+          <a:lstStyle/>
+          <a:p>
+            <a:pPr algn="l"/>
+            <a:r>
+              <a:rPr sz="750" b="0" i="1">
+                <a:solidFill>
+                  <a:srgbClr val="555555"/>
+                </a:solidFill>
+                <a:latin typeface="Calibri"/>
+              </a:rPr>
+              <a:t>Segment principal générant ~85% du CA via des abonnements SaaS et des données en temps réel. Produits phares : FactSet Workstation, FactSet Fundamentals, et FactSet ESG. Clients cibles : hedge funds, asset managers et banques d'investissement. Croissance tirée par l'adoption de l'IA et l'expansion internationale.</a:t>
+            </a:r>
+          </a:p>
+        </p:txBody>
+      </p:sp>
+      <p:sp>
+        <p:nvSpPr>
+          <p:cNvPr id="23" name="Rectangle 22"/>
+          <p:cNvSpPr/>
+          <p:nvPr/>
+        </p:nvSpPr>
+        <p:spPr>
+          <a:xfrm>
+            <a:off x="503999" y="3301199"/>
+            <a:ext cx="64800" cy="64800"/>
+          </a:xfrm>
+          <a:prstGeom prst="rect">
+            <a:avLst/>
+          </a:prstGeom>
+          <a:solidFill>
+            <a:srgbClr val="2E5FA3"/>
+          </a:solidFill>
+          <a:ln>
+            <a:noFill/>
+          </a:ln>
+        </p:spPr>
+        <p:style>
+          <a:lnRef idx="1">
+            <a:schemeClr val="accent1"/>
+          </a:lnRef>
+          <a:fillRef idx="3">
+            <a:schemeClr val="accent1"/>
+          </a:fillRef>
+          <a:effectRef idx="2">
+            <a:schemeClr val="accent1"/>
+          </a:effectRef>
+          <a:fontRef idx="minor">
+            <a:schemeClr val="lt1"/>
+          </a:fontRef>
+        </p:style>
+        <p:txBody>
+          <a:bodyPr rtlCol="0" anchor="ctr"/>
+          <a:lstStyle/>
+          <a:p>
+            <a:pPr algn="ctr"/>
+          </a:p>
+        </p:txBody>
+      </p:sp>
+      <p:sp>
+        <p:nvSpPr>
+          <p:cNvPr id="24" name="TextBox 23"/>
+          <p:cNvSpPr txBox="1"/>
+          <p:nvPr/>
+        </p:nvSpPr>
+        <p:spPr>
+          <a:xfrm>
+            <a:off x="619200" y="3257999"/>
+            <a:ext cx="4338000" cy="165600"/>
+          </a:xfrm>
+          <a:prstGeom prst="rect">
+            <a:avLst/>
+          </a:prstGeom>
+          <a:noFill/>
+        </p:spPr>
+        <p:txBody>
+          <a:bodyPr wrap="square">
+            <a:spAutoFit/>
+          </a:bodyPr>
+          <a:lstStyle/>
+          <a:p>
+            <a:pPr algn="l"/>
+            <a:r>
+              <a:rPr sz="850" b="1" i="0">
+                <a:solidFill>
+                  <a:srgbClr val="0D0D0D"/>
+                </a:solidFill>
+                <a:latin typeface="Calibri"/>
+              </a:rPr>
+              <a:t>Wealth Management Solutions</a:t>
+            </a:r>
+          </a:p>
+        </p:txBody>
+      </p:sp>
+      <p:sp>
+        <p:nvSpPr>
+          <p:cNvPr id="25" name="TextBox 24"/>
+          <p:cNvSpPr txBox="1"/>
+          <p:nvPr/>
+        </p:nvSpPr>
+        <p:spPr>
+          <a:xfrm>
+            <a:off x="619200" y="3416399"/>
+            <a:ext cx="4338000" cy="503999"/>
+          </a:xfrm>
+          <a:prstGeom prst="rect">
+            <a:avLst/>
+          </a:prstGeom>
+          <a:noFill/>
+        </p:spPr>
+        <p:txBody>
+          <a:bodyPr wrap="square">
+            <a:spAutoFit/>
+          </a:bodyPr>
+          <a:lstStyle/>
+          <a:p>
+            <a:pPr algn="l"/>
+            <a:r>
+              <a:rPr sz="750" b="0" i="1">
+                <a:solidFill>
+                  <a:srgbClr val="555555"/>
+                </a:solidFill>
+                <a:latin typeface="Calibri"/>
+              </a:rPr>
+              <a:t>Solutions logicielles pour les conseillers financiers et les family offices. Modèle basé sur des abonnements mensuels avec upselling de modules premium. Produits clés : FactSet Portfolio Analytics et FactSet Wealth. Clients : banques privées et gestionnaires de patrimoine. Moteurs : digitalisation du conseil et réglementations accrues.</a:t>
+            </a:r>
+          </a:p>
+        </p:txBody>
+      </p:sp>
+      <p:sp>
+        <p:nvSpPr>
+          <p:cNvPr id="26" name="Rectangle 25"/>
           <p:cNvSpPr/>
           <p:nvPr/>
         </p:nvSpPr>
@@ -34150,7 +36074,7 @@
       </p:sp>
       <p:sp>
         <p:nvSpPr>
-          <p:cNvPr id="22" name="Rectangle 21"/>
+          <p:cNvPr id="27" name="Rectangle 26"/>
           <p:cNvSpPr/>
           <p:nvPr/>
         </p:nvSpPr>
@@ -34193,7 +36117,7 @@
       </p:sp>
       <p:sp>
         <p:nvSpPr>
-          <p:cNvPr id="23" name="TextBox 22"/>
+          <p:cNvPr id="28" name="TextBox 27"/>
           <p:cNvSpPr txBox="1"/>
           <p:nvPr/>
         </p:nvSpPr>
@@ -34228,7 +36152,7 @@
       </p:sp>
       <p:sp>
         <p:nvSpPr>
-          <p:cNvPr id="24" name="TextBox 23"/>
+          <p:cNvPr id="29" name="TextBox 28"/>
           <p:cNvSpPr txBox="1"/>
           <p:nvPr/>
         </p:nvSpPr>
@@ -34263,7 +36187,7 @@
       </p:sp>
       <p:sp>
         <p:nvSpPr>
-          <p:cNvPr id="25" name="Rectangle 24"/>
+          <p:cNvPr id="30" name="Rectangle 29"/>
           <p:cNvSpPr/>
           <p:nvPr/>
         </p:nvSpPr>
@@ -34306,7 +36230,7 @@
       </p:sp>
       <p:sp>
         <p:nvSpPr>
-          <p:cNvPr id="26" name="Rectangle 25"/>
+          <p:cNvPr id="31" name="Rectangle 30"/>
           <p:cNvSpPr/>
           <p:nvPr/>
         </p:nvSpPr>
@@ -34349,7 +36273,7 @@
       </p:sp>
       <p:sp>
         <p:nvSpPr>
-          <p:cNvPr id="27" name="TextBox 26"/>
+          <p:cNvPr id="32" name="TextBox 31"/>
           <p:cNvSpPr txBox="1"/>
           <p:nvPr/>
         </p:nvSpPr>
@@ -34384,7 +36308,7 @@
       </p:sp>
       <p:sp>
         <p:nvSpPr>
-          <p:cNvPr id="28" name="TextBox 27"/>
+          <p:cNvPr id="33" name="TextBox 32"/>
           <p:cNvSpPr txBox="1"/>
           <p:nvPr/>
         </p:nvSpPr>
@@ -34419,7 +36343,7 @@
       </p:sp>
       <p:sp>
         <p:nvSpPr>
-          <p:cNvPr id="29" name="Rectangle 28"/>
+          <p:cNvPr id="34" name="Rectangle 33"/>
           <p:cNvSpPr/>
           <p:nvPr/>
         </p:nvSpPr>
@@ -34462,7 +36386,7 @@
       </p:sp>
       <p:sp>
         <p:nvSpPr>
-          <p:cNvPr id="30" name="Rectangle 29"/>
+          <p:cNvPr id="35" name="Rectangle 34"/>
           <p:cNvSpPr/>
           <p:nvPr/>
         </p:nvSpPr>
@@ -34505,7 +36429,7 @@
       </p:sp>
       <p:sp>
         <p:nvSpPr>
-          <p:cNvPr id="31" name="TextBox 30"/>
+          <p:cNvPr id="36" name="TextBox 35"/>
           <p:cNvSpPr txBox="1"/>
           <p:nvPr/>
         </p:nvSpPr>
@@ -34540,7 +36464,7 @@
       </p:sp>
       <p:sp>
         <p:nvSpPr>
-          <p:cNvPr id="32" name="TextBox 31"/>
+          <p:cNvPr id="37" name="TextBox 36"/>
           <p:cNvSpPr txBox="1"/>
           <p:nvPr/>
         </p:nvSpPr>
@@ -34575,7 +36499,7 @@
       </p:sp>
       <p:sp>
         <p:nvSpPr>
-          <p:cNvPr id="33" name="Rectangle 32"/>
+          <p:cNvPr id="38" name="Rectangle 37"/>
           <p:cNvSpPr/>
           <p:nvPr/>
         </p:nvSpPr>
@@ -34618,7 +36542,7 @@
       </p:sp>
       <p:sp>
         <p:nvSpPr>
-          <p:cNvPr id="34" name="Rectangle 33"/>
+          <p:cNvPr id="39" name="Rectangle 38"/>
           <p:cNvSpPr/>
           <p:nvPr/>
         </p:nvSpPr>
@@ -34661,7 +36585,7 @@
       </p:sp>
       <p:sp>
         <p:nvSpPr>
-          <p:cNvPr id="35" name="TextBox 34"/>
+          <p:cNvPr id="40" name="TextBox 39"/>
           <p:cNvSpPr txBox="1"/>
           <p:nvPr/>
         </p:nvSpPr>
@@ -34696,7 +36620,7 @@
       </p:sp>
       <p:sp>
         <p:nvSpPr>
-          <p:cNvPr id="36" name="TextBox 35"/>
+          <p:cNvPr id="41" name="TextBox 40"/>
           <p:cNvSpPr txBox="1"/>
           <p:nvPr/>
         </p:nvSpPr>
@@ -34731,7 +36655,7 @@
       </p:sp>
       <p:sp>
         <p:nvSpPr>
-          <p:cNvPr id="37" name="TextBox 36"/>
+          <p:cNvPr id="42" name="TextBox 41"/>
           <p:cNvSpPr txBox="1"/>
           <p:nvPr/>
         </p:nvSpPr>
@@ -35372,7 +37296,7 @@
         <p:spPr>
           <a:xfrm>
             <a:off x="367200" y="961200"/>
-            <a:ext cx="2731199" cy="3520800"/>
+            <a:ext cx="4150800" cy="3520800"/>
           </a:xfrm>
           <a:prstGeom prst="rect">
             <a:avLst/>
@@ -35415,7 +37339,7 @@
         <p:spPr>
           <a:xfrm>
             <a:off x="367200" y="961200"/>
-            <a:ext cx="2731199" cy="54000"/>
+            <a:ext cx="4150800" cy="54000"/>
           </a:xfrm>
           <a:prstGeom prst="rect">
             <a:avLst/>
@@ -35458,7 +37382,7 @@
         <p:spPr>
           <a:xfrm>
             <a:off x="457200" y="1141200"/>
-            <a:ext cx="2551199" cy="640800"/>
+            <a:ext cx="3970800" cy="640800"/>
           </a:xfrm>
           <a:prstGeom prst="rect">
             <a:avLst/>
@@ -35479,7 +37403,7 @@
                 </a:solidFill>
                 <a:latin typeface="Calibri"/>
               </a:rPr>
-              <a:t>—</a:t>
+              <a:t>85%</a:t>
             </a:r>
           </a:p>
         </p:txBody>
@@ -35493,7 +37417,7 @@
         <p:spPr>
           <a:xfrm>
             <a:off x="457200" y="1785600"/>
-            <a:ext cx="2551199" cy="108000"/>
+            <a:ext cx="3970800" cy="108000"/>
           </a:xfrm>
           <a:prstGeom prst="rect">
             <a:avLst/>
@@ -35528,7 +37452,7 @@
         <p:spPr>
           <a:xfrm>
             <a:off x="457200" y="1965600"/>
-            <a:ext cx="2551199" cy="18000"/>
+            <a:ext cx="3970800" cy="18000"/>
           </a:xfrm>
           <a:prstGeom prst="rect">
             <a:avLst/>
@@ -35571,7 +37495,7 @@
         <p:spPr>
           <a:xfrm>
             <a:off x="457200" y="2059200"/>
-            <a:ext cx="2551199" cy="255600"/>
+            <a:ext cx="3970800" cy="255600"/>
           </a:xfrm>
           <a:prstGeom prst="rect">
             <a:avLst/>
@@ -35592,7 +37516,7 @@
                 </a:solidFill>
                 <a:latin typeface="Calibri"/>
               </a:rPr>
-              <a:t>Core Business</a:t>
+              <a:t>Data &amp; Analytics</a:t>
             </a:r>
           </a:p>
         </p:txBody>
@@ -35606,7 +37530,7 @@
         <p:spPr>
           <a:xfrm>
             <a:off x="457200" y="2332800"/>
-            <a:ext cx="2551199" cy="2041199"/>
+            <a:ext cx="3970800" cy="2041199"/>
           </a:xfrm>
           <a:prstGeom prst="rect">
             <a:avLst/>
@@ -35627,7 +37551,7 @@
                 </a:solidFill>
                 <a:latin typeface="Calibri"/>
               </a:rPr>
-              <a:t>—</a:t>
+              <a:t>Segment principal générant ~85% du CA via des abonnements SaaS et des données en temps réel. Produits phares : FactSet Workstation, FactSet Fundamentals, et FactSet ESG. Clients cibles : hedge funds, asset managers et banques d'investissement. Croissance tirée par l'adoption de l'IA et l'expansion internationale.</a:t>
             </a:r>
           </a:p>
         </p:txBody>
@@ -35640,8 +37564,8 @@
         </p:nvSpPr>
         <p:spPr>
           <a:xfrm>
-            <a:off x="3206400" y="961200"/>
-            <a:ext cx="2731199" cy="3520800"/>
+            <a:off x="4626000" y="961200"/>
+            <a:ext cx="4150800" cy="3520800"/>
           </a:xfrm>
           <a:prstGeom prst="rect">
             <a:avLst/>
@@ -35683,8 +37607,8 @@
         </p:nvSpPr>
         <p:spPr>
           <a:xfrm>
-            <a:off x="3206400" y="961200"/>
-            <a:ext cx="2731199" cy="54000"/>
+            <a:off x="4626000" y="961200"/>
+            <a:ext cx="4150800" cy="54000"/>
           </a:xfrm>
           <a:prstGeom prst="rect">
             <a:avLst/>
@@ -35726,8 +37650,8 @@
         </p:nvSpPr>
         <p:spPr>
           <a:xfrm>
-            <a:off x="3296400" y="1141200"/>
-            <a:ext cx="2551199" cy="640800"/>
+            <a:off x="4716000" y="1141200"/>
+            <a:ext cx="3970800" cy="640800"/>
           </a:xfrm>
           <a:prstGeom prst="rect">
             <a:avLst/>
@@ -35748,7 +37672,7 @@
                 </a:solidFill>
                 <a:latin typeface="Calibri"/>
               </a:rPr>
-              <a:t>—</a:t>
+              <a:t>15%</a:t>
             </a:r>
           </a:p>
         </p:txBody>
@@ -35761,8 +37685,8 @@
         </p:nvSpPr>
         <p:spPr>
           <a:xfrm>
-            <a:off x="3296400" y="1785600"/>
-            <a:ext cx="2551199" cy="108000"/>
+            <a:off x="4716000" y="1785600"/>
+            <a:ext cx="3970800" cy="108000"/>
           </a:xfrm>
           <a:prstGeom prst="rect">
             <a:avLst/>
@@ -35796,8 +37720,8 @@
         </p:nvSpPr>
         <p:spPr>
           <a:xfrm>
-            <a:off x="3296400" y="1965600"/>
-            <a:ext cx="2551199" cy="18000"/>
+            <a:off x="4716000" y="1965600"/>
+            <a:ext cx="3970800" cy="18000"/>
           </a:xfrm>
           <a:prstGeom prst="rect">
             <a:avLst/>
@@ -35839,8 +37763,8 @@
         </p:nvSpPr>
         <p:spPr>
           <a:xfrm>
-            <a:off x="3296400" y="2059200"/>
-            <a:ext cx="2551199" cy="255600"/>
+            <a:off x="4716000" y="2059200"/>
+            <a:ext cx="3970800" cy="255600"/>
           </a:xfrm>
           <a:prstGeom prst="rect">
             <a:avLst/>
@@ -35861,7 +37785,7 @@
                 </a:solidFill>
                 <a:latin typeface="Calibri"/>
               </a:rPr>
-              <a:t>Growth Driver</a:t>
+              <a:t>Wealth Management Solutions</a:t>
             </a:r>
           </a:p>
         </p:txBody>
@@ -35874,8 +37798,8 @@
         </p:nvSpPr>
         <p:spPr>
           <a:xfrm>
-            <a:off x="3296400" y="2332800"/>
-            <a:ext cx="2551199" cy="2041199"/>
+            <a:off x="4716000" y="2332800"/>
+            <a:ext cx="3970800" cy="2041199"/>
           </a:xfrm>
           <a:prstGeom prst="rect">
             <a:avLst/>
@@ -35896,276 +37820,7 @@
                 </a:solidFill>
                 <a:latin typeface="Calibri"/>
               </a:rPr>
-              <a:t>—</a:t>
-            </a:r>
-          </a:p>
-        </p:txBody>
-      </p:sp>
-      <p:sp>
-        <p:nvSpPr>
-          <p:cNvPr id="31" name="Rectangle 30"/>
-          <p:cNvSpPr/>
-          <p:nvPr/>
-        </p:nvSpPr>
-        <p:spPr>
-          <a:xfrm>
-            <a:off x="6045600" y="961200"/>
-            <a:ext cx="2731199" cy="3520800"/>
-          </a:xfrm>
-          <a:prstGeom prst="rect">
-            <a:avLst/>
-          </a:prstGeom>
-          <a:solidFill>
-            <a:srgbClr val="F7F8FA"/>
-          </a:solidFill>
-          <a:ln>
-            <a:noFill/>
-          </a:ln>
-        </p:spPr>
-        <p:style>
-          <a:lnRef idx="1">
-            <a:schemeClr val="accent1"/>
-          </a:lnRef>
-          <a:fillRef idx="3">
-            <a:schemeClr val="accent1"/>
-          </a:fillRef>
-          <a:effectRef idx="2">
-            <a:schemeClr val="accent1"/>
-          </a:effectRef>
-          <a:fontRef idx="minor">
-            <a:schemeClr val="lt1"/>
-          </a:fontRef>
-        </p:style>
-        <p:txBody>
-          <a:bodyPr rtlCol="0" anchor="ctr"/>
-          <a:lstStyle/>
-          <a:p>
-            <a:pPr algn="ctr"/>
-          </a:p>
-        </p:txBody>
-      </p:sp>
-      <p:sp>
-        <p:nvSpPr>
-          <p:cNvPr id="32" name="Rectangle 31"/>
-          <p:cNvSpPr/>
-          <p:nvPr/>
-        </p:nvSpPr>
-        <p:spPr>
-          <a:xfrm>
-            <a:off x="6045600" y="961200"/>
-            <a:ext cx="2731199" cy="54000"/>
-          </a:xfrm>
-          <a:prstGeom prst="rect">
-            <a:avLst/>
-          </a:prstGeom>
-          <a:solidFill>
-            <a:srgbClr val="888888"/>
-          </a:solidFill>
-          <a:ln>
-            <a:noFill/>
-          </a:ln>
-        </p:spPr>
-        <p:style>
-          <a:lnRef idx="1">
-            <a:schemeClr val="accent1"/>
-          </a:lnRef>
-          <a:fillRef idx="3">
-            <a:schemeClr val="accent1"/>
-          </a:fillRef>
-          <a:effectRef idx="2">
-            <a:schemeClr val="accent1"/>
-          </a:effectRef>
-          <a:fontRef idx="minor">
-            <a:schemeClr val="lt1"/>
-          </a:fontRef>
-        </p:style>
-        <p:txBody>
-          <a:bodyPr rtlCol="0" anchor="ctr"/>
-          <a:lstStyle/>
-          <a:p>
-            <a:pPr algn="ctr"/>
-          </a:p>
-        </p:txBody>
-      </p:sp>
-      <p:sp>
-        <p:nvSpPr>
-          <p:cNvPr id="33" name="TextBox 32"/>
-          <p:cNvSpPr txBox="1"/>
-          <p:nvPr/>
-        </p:nvSpPr>
-        <p:spPr>
-          <a:xfrm>
-            <a:off x="6135600" y="1141200"/>
-            <a:ext cx="2551199" cy="640800"/>
-          </a:xfrm>
-          <a:prstGeom prst="rect">
-            <a:avLst/>
-          </a:prstGeom>
-          <a:noFill/>
-        </p:spPr>
-        <p:txBody>
-          <a:bodyPr wrap="square">
-            <a:spAutoFit/>
-          </a:bodyPr>
-          <a:lstStyle/>
-          <a:p>
-            <a:pPr algn="l"/>
-            <a:r>
-              <a:rPr sz="2200" b="1" i="0">
-                <a:solidFill>
-                  <a:srgbClr val="888888"/>
-                </a:solidFill>
-                <a:latin typeface="Calibri"/>
-              </a:rPr>
-              <a:t>—</a:t>
-            </a:r>
-          </a:p>
-        </p:txBody>
-      </p:sp>
-      <p:sp>
-        <p:nvSpPr>
-          <p:cNvPr id="34" name="TextBox 33"/>
-          <p:cNvSpPr txBox="1"/>
-          <p:nvPr/>
-        </p:nvSpPr>
-        <p:spPr>
-          <a:xfrm>
-            <a:off x="6135600" y="1785600"/>
-            <a:ext cx="2551199" cy="108000"/>
-          </a:xfrm>
-          <a:prstGeom prst="rect">
-            <a:avLst/>
-          </a:prstGeom>
-          <a:noFill/>
-        </p:spPr>
-        <p:txBody>
-          <a:bodyPr wrap="square">
-            <a:spAutoFit/>
-          </a:bodyPr>
-          <a:lstStyle/>
-          <a:p>
-            <a:pPr algn="l"/>
-            <a:r>
-              <a:rPr sz="900" b="0" i="0">
-                <a:solidFill>
-                  <a:srgbClr val="555555"/>
-                </a:solidFill>
-                <a:latin typeface="Calibri"/>
-              </a:rPr>
-              <a:t>du CA</a:t>
-            </a:r>
-          </a:p>
-        </p:txBody>
-      </p:sp>
-      <p:sp>
-        <p:nvSpPr>
-          <p:cNvPr id="35" name="Rectangle 34"/>
-          <p:cNvSpPr/>
-          <p:nvPr/>
-        </p:nvSpPr>
-        <p:spPr>
-          <a:xfrm>
-            <a:off x="6135600" y="1965600"/>
-            <a:ext cx="2551199" cy="18000"/>
-          </a:xfrm>
-          <a:prstGeom prst="rect">
-            <a:avLst/>
-          </a:prstGeom>
-          <a:solidFill>
-            <a:srgbClr val="888888"/>
-          </a:solidFill>
-          <a:ln>
-            <a:noFill/>
-          </a:ln>
-        </p:spPr>
-        <p:style>
-          <a:lnRef idx="1">
-            <a:schemeClr val="accent1"/>
-          </a:lnRef>
-          <a:fillRef idx="3">
-            <a:schemeClr val="accent1"/>
-          </a:fillRef>
-          <a:effectRef idx="2">
-            <a:schemeClr val="accent1"/>
-          </a:effectRef>
-          <a:fontRef idx="minor">
-            <a:schemeClr val="lt1"/>
-          </a:fontRef>
-        </p:style>
-        <p:txBody>
-          <a:bodyPr rtlCol="0" anchor="ctr"/>
-          <a:lstStyle/>
-          <a:p>
-            <a:pPr algn="ctr"/>
-          </a:p>
-        </p:txBody>
-      </p:sp>
-      <p:sp>
-        <p:nvSpPr>
-          <p:cNvPr id="36" name="TextBox 35"/>
-          <p:cNvSpPr txBox="1"/>
-          <p:nvPr/>
-        </p:nvSpPr>
-        <p:spPr>
-          <a:xfrm>
-            <a:off x="6135600" y="2059200"/>
-            <a:ext cx="2551199" cy="255600"/>
-          </a:xfrm>
-          <a:prstGeom prst="rect">
-            <a:avLst/>
-          </a:prstGeom>
-          <a:noFill/>
-        </p:spPr>
-        <p:txBody>
-          <a:bodyPr wrap="square">
-            <a:spAutoFit/>
-          </a:bodyPr>
-          <a:lstStyle/>
-          <a:p>
-            <a:pPr algn="l"/>
-            <a:r>
-              <a:rPr sz="1000" b="1" i="0">
-                <a:solidFill>
-                  <a:srgbClr val="1B3A6B"/>
-                </a:solidFill>
-                <a:latin typeface="Calibri"/>
-              </a:rPr>
-              <a:t>International</a:t>
-            </a:r>
-          </a:p>
-        </p:txBody>
-      </p:sp>
-      <p:sp>
-        <p:nvSpPr>
-          <p:cNvPr id="37" name="TextBox 36"/>
-          <p:cNvSpPr txBox="1"/>
-          <p:nvPr/>
-        </p:nvSpPr>
-        <p:spPr>
-          <a:xfrm>
-            <a:off x="6135600" y="2332800"/>
-            <a:ext cx="2551199" cy="2041199"/>
-          </a:xfrm>
-          <a:prstGeom prst="rect">
-            <a:avLst/>
-          </a:prstGeom>
-          <a:noFill/>
-        </p:spPr>
-        <p:txBody>
-          <a:bodyPr wrap="square">
-            <a:spAutoFit/>
-          </a:bodyPr>
-          <a:lstStyle/>
-          <a:p>
-            <a:pPr algn="l"/>
-            <a:r>
-              <a:rPr sz="800" b="0" i="0">
-                <a:solidFill>
-                  <a:srgbClr val="555555"/>
-                </a:solidFill>
-                <a:latin typeface="Calibri"/>
-              </a:rPr>
-              <a:t>—</a:t>
+              <a:t>Solutions logicielles pour les conseillers financiers et les family offices. Modèle basé sur des abonnements mensuels avec upselling de modules premium. Produits clés : FactSet Portfolio Analytics et FactSet Wealth. Clients : banques privées et gestionnaires de patrimoine. Moteurs : digitalisation du conseil et réglementations accrues.</a:t>
             </a:r>
           </a:p>
         </p:txBody>
@@ -37017,7 +38672,7 @@
                 </a:solidFill>
                 <a:latin typeface="Calibri"/>
               </a:rPr>
-              <a:t>USD millions  ·  2022–2025</a:t>
+              <a:t>USD millions  ·  2022–2027F</a:t>
             </a:r>
           </a:p>
         </p:txBody>
@@ -37032,7 +38687,7 @@
         </p:nvGraphicFramePr>
         <p:xfrm>
           <a:off x="367200" y="914400"/>
-          <a:ext cx="8413200" cy="1980000"/>
+          <a:ext cx="8413196" cy="1980000"/>
         </p:xfrm>
         <a:graphic>
           <a:graphicData uri="http://schemas.openxmlformats.org/drawingml/2006/table">
@@ -37042,9 +38697,11 @@
               </a:tblPr>
               <a:tblGrid>
                 <a:gridCol w="2355696"/>
-                <a:gridCol w="2019168"/>
-                <a:gridCol w="2019168"/>
-                <a:gridCol w="2019168"/>
+                <a:gridCol w="1211500"/>
+                <a:gridCol w="1211500"/>
+                <a:gridCol w="1211500"/>
+                <a:gridCol w="1211500"/>
+                <a:gridCol w="1211500"/>
               </a:tblGrid>
               <a:tr h="220000">
                 <a:tc>
@@ -37139,6 +38796,52 @@
                     </a:solidFill>
                   </a:tcPr>
                 </a:tc>
+                <a:tc>
+                  <a:txBody>
+                    <a:bodyPr/>
+                    <a:lstStyle/>
+                    <a:p>
+                      <a:pPr algn="ctr"/>
+                      <a:r>
+                        <a:rPr sz="800" b="1" i="0">
+                          <a:solidFill>
+                            <a:srgbClr val="FFFFFF"/>
+                          </a:solidFill>
+                          <a:latin typeface="Calibri"/>
+                        </a:rPr>
+                        <a:t>2026F</a:t>
+                      </a:r>
+                    </a:p>
+                  </a:txBody>
+                  <a:tcPr>
+                    <a:solidFill>
+                      <a:srgbClr val="1B3A6B"/>
+                    </a:solidFill>
+                  </a:tcPr>
+                </a:tc>
+                <a:tc>
+                  <a:txBody>
+                    <a:bodyPr/>
+                    <a:lstStyle/>
+                    <a:p>
+                      <a:pPr algn="ctr"/>
+                      <a:r>
+                        <a:rPr sz="800" b="1" i="0">
+                          <a:solidFill>
+                            <a:srgbClr val="FFFFFF"/>
+                          </a:solidFill>
+                          <a:latin typeface="Calibri"/>
+                        </a:rPr>
+                        <a:t>2027F</a:t>
+                      </a:r>
+                    </a:p>
+                  </a:txBody>
+                  <a:tcPr>
+                    <a:solidFill>
+                      <a:srgbClr val="1B3A6B"/>
+                    </a:solidFill>
+                  </a:tcPr>
+                </a:tc>
               </a:tr>
               <a:tr h="220000">
                 <a:tc>
@@ -37233,6 +38936,52 @@
                     </a:solidFill>
                   </a:tcPr>
                 </a:tc>
+                <a:tc>
+                  <a:txBody>
+                    <a:bodyPr/>
+                    <a:lstStyle/>
+                    <a:p>
+                      <a:pPr algn="ctr"/>
+                      <a:r>
+                        <a:rPr sz="800" b="1" i="0">
+                          <a:solidFill>
+                            <a:srgbClr val="0D0D0D"/>
+                          </a:solidFill>
+                          <a:latin typeface="Calibri"/>
+                        </a:rPr>
+                        <a:t>2,4</a:t>
+                      </a:r>
+                    </a:p>
+                  </a:txBody>
+                  <a:tcPr>
+                    <a:solidFill>
+                      <a:srgbClr val="FFFFFF"/>
+                    </a:solidFill>
+                  </a:tcPr>
+                </a:tc>
+                <a:tc>
+                  <a:txBody>
+                    <a:bodyPr/>
+                    <a:lstStyle/>
+                    <a:p>
+                      <a:pPr algn="ctr"/>
+                      <a:r>
+                        <a:rPr sz="800" b="1" i="0">
+                          <a:solidFill>
+                            <a:srgbClr val="0D0D0D"/>
+                          </a:solidFill>
+                          <a:latin typeface="Calibri"/>
+                        </a:rPr>
+                        <a:t>2,6</a:t>
+                      </a:r>
+                    </a:p>
+                  </a:txBody>
+                  <a:tcPr>
+                    <a:solidFill>
+                      <a:srgbClr val="FFFFFF"/>
+                    </a:solidFill>
+                  </a:tcPr>
+                </a:tc>
               </a:tr>
               <a:tr h="220000">
                 <a:tc>
@@ -37327,6 +39076,52 @@
                     </a:solidFill>
                   </a:tcPr>
                 </a:tc>
+                <a:tc>
+                  <a:txBody>
+                    <a:bodyPr/>
+                    <a:lstStyle/>
+                    <a:p>
+                      <a:pPr algn="ctr"/>
+                      <a:r>
+                        <a:rPr sz="750" b="0" i="1">
+                          <a:solidFill>
+                            <a:srgbClr val="333333"/>
+                          </a:solidFill>
+                          <a:latin typeface="Calibri"/>
+                        </a:rPr>
+                        <a:t>+5,3 %</a:t>
+                      </a:r>
+                    </a:p>
+                  </a:txBody>
+                  <a:tcPr>
+                    <a:solidFill>
+                      <a:srgbClr val="F7F8FA"/>
+                    </a:solidFill>
+                  </a:tcPr>
+                </a:tc>
+                <a:tc>
+                  <a:txBody>
+                    <a:bodyPr/>
+                    <a:lstStyle/>
+                    <a:p>
+                      <a:pPr algn="ctr"/>
+                      <a:r>
+                        <a:rPr sz="750" b="0" i="1">
+                          <a:solidFill>
+                            <a:srgbClr val="333333"/>
+                          </a:solidFill>
+                          <a:latin typeface="Calibri"/>
+                        </a:rPr>
+                        <a:t>+5,4 %</a:t>
+                      </a:r>
+                    </a:p>
+                  </a:txBody>
+                  <a:tcPr>
+                    <a:solidFill>
+                      <a:srgbClr val="F7F8FA"/>
+                    </a:solidFill>
+                  </a:tcPr>
+                </a:tc>
               </a:tr>
               <a:tr h="220000">
                 <a:tc>
@@ -37421,6 +39216,52 @@
                     </a:solidFill>
                   </a:tcPr>
                 </a:tc>
+                <a:tc>
+                  <a:txBody>
+                    <a:bodyPr/>
+                    <a:lstStyle/>
+                    <a:p>
+                      <a:pPr algn="ctr"/>
+                      <a:r>
+                        <a:rPr sz="800" b="1" i="0">
+                          <a:solidFill>
+                            <a:srgbClr val="0D0D0D"/>
+                          </a:solidFill>
+                          <a:latin typeface="Calibri"/>
+                        </a:rPr>
+                        <a:t>1,3</a:t>
+                      </a:r>
+                    </a:p>
+                  </a:txBody>
+                  <a:tcPr>
+                    <a:solidFill>
+                      <a:srgbClr val="FFFFFF"/>
+                    </a:solidFill>
+                  </a:tcPr>
+                </a:tc>
+                <a:tc>
+                  <a:txBody>
+                    <a:bodyPr/>
+                    <a:lstStyle/>
+                    <a:p>
+                      <a:pPr algn="ctr"/>
+                      <a:r>
+                        <a:rPr sz="800" b="1" i="0">
+                          <a:solidFill>
+                            <a:srgbClr val="0D0D0D"/>
+                          </a:solidFill>
+                          <a:latin typeface="Calibri"/>
+                        </a:rPr>
+                        <a:t>1,4</a:t>
+                      </a:r>
+                    </a:p>
+                  </a:txBody>
+                  <a:tcPr>
+                    <a:solidFill>
+                      <a:srgbClr val="FFFFFF"/>
+                    </a:solidFill>
+                  </a:tcPr>
+                </a:tc>
               </a:tr>
               <a:tr h="220000">
                 <a:tc>
@@ -37515,6 +39356,52 @@
                     </a:solidFill>
                   </a:tcPr>
                 </a:tc>
+                <a:tc>
+                  <a:txBody>
+                    <a:bodyPr/>
+                    <a:lstStyle/>
+                    <a:p>
+                      <a:pPr algn="ctr"/>
+                      <a:r>
+                        <a:rPr sz="750" b="0" i="1">
+                          <a:solidFill>
+                            <a:srgbClr val="333333"/>
+                          </a:solidFill>
+                          <a:latin typeface="Calibri"/>
+                        </a:rPr>
+                        <a:t>53,0 %</a:t>
+                      </a:r>
+                    </a:p>
+                  </a:txBody>
+                  <a:tcPr>
+                    <a:solidFill>
+                      <a:srgbClr val="F7F8FA"/>
+                    </a:solidFill>
+                  </a:tcPr>
+                </a:tc>
+                <a:tc>
+                  <a:txBody>
+                    <a:bodyPr/>
+                    <a:lstStyle/>
+                    <a:p>
+                      <a:pPr algn="ctr"/>
+                      <a:r>
+                        <a:rPr sz="750" b="0" i="1">
+                          <a:solidFill>
+                            <a:srgbClr val="333333"/>
+                          </a:solidFill>
+                          <a:latin typeface="Calibri"/>
+                        </a:rPr>
+                        <a:t>53,5 %</a:t>
+                      </a:r>
+                    </a:p>
+                  </a:txBody>
+                  <a:tcPr>
+                    <a:solidFill>
+                      <a:srgbClr val="F7F8FA"/>
+                    </a:solidFill>
+                  </a:tcPr>
+                </a:tc>
               </a:tr>
               <a:tr h="220000">
                 <a:tc>
@@ -37609,6 +39496,52 @@
                     </a:solidFill>
                   </a:tcPr>
                 </a:tc>
+                <a:tc>
+                  <a:txBody>
+                    <a:bodyPr/>
+                    <a:lstStyle/>
+                    <a:p>
+                      <a:pPr algn="ctr"/>
+                      <a:r>
+                        <a:rPr sz="800" b="1" i="0">
+                          <a:solidFill>
+                            <a:srgbClr val="0D0D0D"/>
+                          </a:solidFill>
+                          <a:latin typeface="Calibri"/>
+                        </a:rPr>
+                        <a:t>1,0</a:t>
+                      </a:r>
+                    </a:p>
+                  </a:txBody>
+                  <a:tcPr>
+                    <a:solidFill>
+                      <a:srgbClr val="FFFFFF"/>
+                    </a:solidFill>
+                  </a:tcPr>
+                </a:tc>
+                <a:tc>
+                  <a:txBody>
+                    <a:bodyPr/>
+                    <a:lstStyle/>
+                    <a:p>
+                      <a:pPr algn="ctr"/>
+                      <a:r>
+                        <a:rPr sz="800" b="1" i="0">
+                          <a:solidFill>
+                            <a:srgbClr val="0D0D0D"/>
+                          </a:solidFill>
+                          <a:latin typeface="Calibri"/>
+                        </a:rPr>
+                        <a:t>1,1</a:t>
+                      </a:r>
+                    </a:p>
+                  </a:txBody>
+                  <a:tcPr>
+                    <a:solidFill>
+                      <a:srgbClr val="FFFFFF"/>
+                    </a:solidFill>
+                  </a:tcPr>
+                </a:tc>
               </a:tr>
               <a:tr h="220000">
                 <a:tc>
@@ -37703,6 +39636,52 @@
                     </a:solidFill>
                   </a:tcPr>
                 </a:tc>
+                <a:tc>
+                  <a:txBody>
+                    <a:bodyPr/>
+                    <a:lstStyle/>
+                    <a:p>
+                      <a:pPr algn="ctr"/>
+                      <a:r>
+                        <a:rPr sz="750" b="0" i="1">
+                          <a:solidFill>
+                            <a:srgbClr val="333333"/>
+                          </a:solidFill>
+                          <a:latin typeface="Calibri"/>
+                        </a:rPr>
+                        <a:t>41,6 %</a:t>
+                      </a:r>
+                    </a:p>
+                  </a:txBody>
+                  <a:tcPr>
+                    <a:solidFill>
+                      <a:srgbClr val="F7F8FA"/>
+                    </a:solidFill>
+                  </a:tcPr>
+                </a:tc>
+                <a:tc>
+                  <a:txBody>
+                    <a:bodyPr/>
+                    <a:lstStyle/>
+                    <a:p>
+                      <a:pPr algn="ctr"/>
+                      <a:r>
+                        <a:rPr sz="750" b="0" i="1">
+                          <a:solidFill>
+                            <a:srgbClr val="333333"/>
+                          </a:solidFill>
+                          <a:latin typeface="Calibri"/>
+                        </a:rPr>
+                        <a:t>42,1 %</a:t>
+                      </a:r>
+                    </a:p>
+                  </a:txBody>
+                  <a:tcPr>
+                    <a:solidFill>
+                      <a:srgbClr val="F7F8FA"/>
+                    </a:solidFill>
+                  </a:tcPr>
+                </a:tc>
               </a:tr>
               <a:tr h="220000">
                 <a:tc>
@@ -37797,6 +39776,52 @@
                     </a:solidFill>
                   </a:tcPr>
                 </a:tc>
+                <a:tc>
+                  <a:txBody>
+                    <a:bodyPr/>
+                    <a:lstStyle/>
+                    <a:p>
+                      <a:pPr algn="ctr"/>
+                      <a:r>
+                        <a:rPr sz="800" b="1" i="0">
+                          <a:solidFill>
+                            <a:srgbClr val="0D0D0D"/>
+                          </a:solidFill>
+                          <a:latin typeface="Calibri"/>
+                        </a:rPr>
+                        <a:t>0,6</a:t>
+                      </a:r>
+                    </a:p>
+                  </a:txBody>
+                  <a:tcPr>
+                    <a:solidFill>
+                      <a:srgbClr val="FFFFFF"/>
+                    </a:solidFill>
+                  </a:tcPr>
+                </a:tc>
+                <a:tc>
+                  <a:txBody>
+                    <a:bodyPr/>
+                    <a:lstStyle/>
+                    <a:p>
+                      <a:pPr algn="ctr"/>
+                      <a:r>
+                        <a:rPr sz="800" b="1" i="0">
+                          <a:solidFill>
+                            <a:srgbClr val="0D0D0D"/>
+                          </a:solidFill>
+                          <a:latin typeface="Calibri"/>
+                        </a:rPr>
+                        <a:t>0,6</a:t>
+                      </a:r>
+                    </a:p>
+                  </a:txBody>
+                  <a:tcPr>
+                    <a:solidFill>
+                      <a:srgbClr val="FFFFFF"/>
+                    </a:solidFill>
+                  </a:tcPr>
+                </a:tc>
               </a:tr>
               <a:tr h="220000">
                 <a:tc>
@@ -37888,6 +39913,52 @@
                   <a:tcPr>
                     <a:solidFill>
                       <a:srgbClr val="DDE8F5"/>
+                    </a:solidFill>
+                  </a:tcPr>
+                </a:tc>
+                <a:tc>
+                  <a:txBody>
+                    <a:bodyPr/>
+                    <a:lstStyle/>
+                    <a:p>
+                      <a:pPr algn="ctr"/>
+                      <a:r>
+                        <a:rPr sz="750" b="0" i="1">
+                          <a:solidFill>
+                            <a:srgbClr val="333333"/>
+                          </a:solidFill>
+                          <a:latin typeface="Calibri"/>
+                        </a:rPr>
+                        <a:t>24,6 %</a:t>
+                      </a:r>
+                    </a:p>
+                  </a:txBody>
+                  <a:tcPr>
+                    <a:solidFill>
+                      <a:srgbClr val="F7F8FA"/>
+                    </a:solidFill>
+                  </a:tcPr>
+                </a:tc>
+                <a:tc>
+                  <a:txBody>
+                    <a:bodyPr/>
+                    <a:lstStyle/>
+                    <a:p>
+                      <a:pPr algn="ctr"/>
+                      <a:r>
+                        <a:rPr sz="750" b="0" i="1">
+                          <a:solidFill>
+                            <a:srgbClr val="333333"/>
+                          </a:solidFill>
+                          <a:latin typeface="Calibri"/>
+                        </a:rPr>
+                        <a:t>25,0 %</a:t>
+                      </a:r>
+                    </a:p>
+                  </a:txBody>
+                  <a:tcPr>
+                    <a:solidFill>
+                      <a:srgbClr val="F7F8FA"/>
                     </a:solidFill>
                   </a:tcPr>
                 </a:tc>
@@ -37896,6 +39967,127 @@
           </a:graphicData>
         </a:graphic>
       </p:graphicFrame>
+      <p:sp>
+        <p:nvSpPr>
+          <p:cNvPr id="18" name="Rectangle 17"/>
+          <p:cNvSpPr/>
+          <p:nvPr/>
+        </p:nvSpPr>
+        <p:spPr>
+          <a:xfrm>
+            <a:off x="367200" y="3218400"/>
+            <a:ext cx="8413200" cy="1224000"/>
+          </a:xfrm>
+          <a:prstGeom prst="rect">
+            <a:avLst/>
+          </a:prstGeom>
+          <a:solidFill>
+            <a:srgbClr val="F5F7FA"/>
+          </a:solidFill>
+          <a:ln>
+            <a:noFill/>
+          </a:ln>
+        </p:spPr>
+        <p:style>
+          <a:lnRef idx="1">
+            <a:schemeClr val="accent1"/>
+          </a:lnRef>
+          <a:fillRef idx="3">
+            <a:schemeClr val="accent1"/>
+          </a:fillRef>
+          <a:effectRef idx="2">
+            <a:schemeClr val="accent1"/>
+          </a:effectRef>
+          <a:fontRef idx="minor">
+            <a:schemeClr val="lt1"/>
+          </a:fontRef>
+        </p:style>
+        <p:txBody>
+          <a:bodyPr rtlCol="0" anchor="ctr"/>
+          <a:lstStyle/>
+          <a:p>
+            <a:pPr algn="ctr"/>
+          </a:p>
+        </p:txBody>
+      </p:sp>
+      <p:sp>
+        <p:nvSpPr>
+          <p:cNvPr id="19" name="Rectangle 18"/>
+          <p:cNvSpPr/>
+          <p:nvPr/>
+        </p:nvSpPr>
+        <p:spPr>
+          <a:xfrm>
+            <a:off x="367200" y="3218400"/>
+            <a:ext cx="79200" cy="1224000"/>
+          </a:xfrm>
+          <a:prstGeom prst="rect">
+            <a:avLst/>
+          </a:prstGeom>
+          <a:solidFill>
+            <a:srgbClr val="2E5FA3"/>
+          </a:solidFill>
+          <a:ln>
+            <a:noFill/>
+          </a:ln>
+        </p:spPr>
+        <p:style>
+          <a:lnRef idx="1">
+            <a:schemeClr val="accent1"/>
+          </a:lnRef>
+          <a:fillRef idx="3">
+            <a:schemeClr val="accent1"/>
+          </a:fillRef>
+          <a:effectRef idx="2">
+            <a:schemeClr val="accent1"/>
+          </a:effectRef>
+          <a:fontRef idx="minor">
+            <a:schemeClr val="lt1"/>
+          </a:fontRef>
+        </p:style>
+        <p:txBody>
+          <a:bodyPr rtlCol="0" anchor="ctr"/>
+          <a:lstStyle/>
+          <a:p>
+            <a:pPr algn="ctr"/>
+          </a:p>
+        </p:txBody>
+      </p:sp>
+      <p:sp>
+        <p:nvSpPr>
+          <p:cNvPr id="20" name="TextBox 19"/>
+          <p:cNvSpPr txBox="1"/>
+          <p:nvPr/>
+        </p:nvSpPr>
+        <p:spPr>
+          <a:xfrm>
+            <a:off x="475200" y="3247200"/>
+            <a:ext cx="8298000" cy="1188000"/>
+          </a:xfrm>
+          <a:prstGeom prst="rect">
+            <a:avLst/>
+          </a:prstGeom>
+          <a:noFill/>
+        </p:spPr>
+        <p:txBody>
+          <a:bodyPr wrap="square">
+            <a:spAutoFit/>
+          </a:bodyPr>
+          <a:lstStyle/>
+          <a:p>
+            <a:pPr algn="l"/>
+            <a:r>
+              <a:rPr sz="850" b="0" i="0">
+                <a:solidFill>
+                  <a:srgbClr val="555555"/>
+                </a:solidFill>
+                <a:latin typeface="Calibri"/>
+              </a:rPr>
+              <a:t>Le CA 2025 atteint 2,321.8M$ (+5.4% YoY) avec une marge brute stable à 52.7%. Le levier opérationnel de +2.0pts sur l'EBITDA (41.6%) s'explique par l'effet volume et la mixité vers des solutions logicielles haute marge. Le ND/EBITDA de 1.1x et l'IntCov de 13.8x confirment une solidité financière permettant 500M$ de rachats ou dividendes.</a:t>
+            </a:r>
+          </a:p>
+        </p:txBody>
+      </p:sp>
     </p:spTree>
   </p:cSld>
   <p:clrMapOvr>
@@ -39778,6 +41970,127 @@
           </a:graphicData>
         </a:graphic>
       </p:graphicFrame>
+      <p:sp>
+        <p:nvSpPr>
+          <p:cNvPr id="31" name="Rectangle 30"/>
+          <p:cNvSpPr/>
+          <p:nvPr/>
+        </p:nvSpPr>
+        <p:spPr>
+          <a:xfrm>
+            <a:off x="367200" y="4068000"/>
+            <a:ext cx="8413200" cy="468000"/>
+          </a:xfrm>
+          <a:prstGeom prst="rect">
+            <a:avLst/>
+          </a:prstGeom>
+          <a:solidFill>
+            <a:srgbClr val="F5F7FA"/>
+          </a:solidFill>
+          <a:ln>
+            <a:noFill/>
+          </a:ln>
+        </p:spPr>
+        <p:style>
+          <a:lnRef idx="1">
+            <a:schemeClr val="accent1"/>
+          </a:lnRef>
+          <a:fillRef idx="3">
+            <a:schemeClr val="accent1"/>
+          </a:fillRef>
+          <a:effectRef idx="2">
+            <a:schemeClr val="accent1"/>
+          </a:effectRef>
+          <a:fontRef idx="minor">
+            <a:schemeClr val="lt1"/>
+          </a:fontRef>
+        </p:style>
+        <p:txBody>
+          <a:bodyPr rtlCol="0" anchor="ctr"/>
+          <a:lstStyle/>
+          <a:p>
+            <a:pPr algn="ctr"/>
+          </a:p>
+        </p:txBody>
+      </p:sp>
+      <p:sp>
+        <p:nvSpPr>
+          <p:cNvPr id="32" name="Rectangle 31"/>
+          <p:cNvSpPr/>
+          <p:nvPr/>
+        </p:nvSpPr>
+        <p:spPr>
+          <a:xfrm>
+            <a:off x="367200" y="4068000"/>
+            <a:ext cx="79200" cy="468000"/>
+          </a:xfrm>
+          <a:prstGeom prst="rect">
+            <a:avLst/>
+          </a:prstGeom>
+          <a:solidFill>
+            <a:srgbClr val="2E5FA3"/>
+          </a:solidFill>
+          <a:ln>
+            <a:noFill/>
+          </a:ln>
+        </p:spPr>
+        <p:style>
+          <a:lnRef idx="1">
+            <a:schemeClr val="accent1"/>
+          </a:lnRef>
+          <a:fillRef idx="3">
+            <a:schemeClr val="accent1"/>
+          </a:fillRef>
+          <a:effectRef idx="2">
+            <a:schemeClr val="accent1"/>
+          </a:effectRef>
+          <a:fontRef idx="minor">
+            <a:schemeClr val="lt1"/>
+          </a:fontRef>
+        </p:style>
+        <p:txBody>
+          <a:bodyPr rtlCol="0" anchor="ctr"/>
+          <a:lstStyle/>
+          <a:p>
+            <a:pPr algn="ctr"/>
+          </a:p>
+        </p:txBody>
+      </p:sp>
+      <p:sp>
+        <p:nvSpPr>
+          <p:cNvPr id="33" name="TextBox 32"/>
+          <p:cNvSpPr txBox="1"/>
+          <p:nvPr/>
+        </p:nvSpPr>
+        <p:spPr>
+          <a:xfrm>
+            <a:off x="475200" y="4096800"/>
+            <a:ext cx="8298000" cy="432000"/>
+          </a:xfrm>
+          <a:prstGeom prst="rect">
+            <a:avLst/>
+          </a:prstGeom>
+          <a:noFill/>
+        </p:spPr>
+        <p:txBody>
+          <a:bodyPr wrap="square">
+            <a:spAutoFit/>
+          </a:bodyPr>
+          <a:lstStyle/>
+          <a:p>
+            <a:pPr algn="l"/>
+            <a:r>
+              <a:rPr sz="850" b="0" i="0">
+                <a:solidFill>
+                  <a:srgbClr val="555555"/>
+                </a:solidFill>
+                <a:latin typeface="Calibri"/>
+              </a:rPr>
+              <a:t>Le CA 2025 atteint 2,321.8M$ (+5.4% YoY) avec une marge brute stable à 52.7%. Le levier opérationnel de +2.0pts sur l'EBITDA (41.6%) s'explique par l'effet volume et la mixité vers des solutions logicielles haute marge. Le ND/EBITDA de 1.1x et l'IntCov de 13.8x confirment une solidité financière permettant 500M$ de rachats ou dividendes.</a:t>
+            </a:r>
+          </a:p>
+        </p:txBody>
+      </p:sp>
     </p:spTree>
   </p:cSld>
   <p:clrMapOvr>

</xml_diff>